<commit_message>
Center Pattern Matching Suppression on the original instruction-following task
</commit_message>
<xml_diff>
--- a/slides/datasets-in-10-minutes-pattern-matching-suppression.pptx
+++ b/slides/datasets-in-10-minutes-pattern-matching-suppression.pptx
@@ -30,8 +30,6 @@
     <p:sldId id="278" r:id="rId28"/>
     <p:sldId id="279" r:id="rId29"/>
     <p:sldId id="280" r:id="rId30"/>
-    <p:sldId id="281" r:id="rId31"/>
-    <p:sldId id="282" r:id="rId32"/>
     <p:sldId id="284" r:id="rId34"/>
     <p:sldId id="285" r:id="rId35"/>
     <p:sldId id="286" r:id="rId36"/>
@@ -55,7 +53,6 @@
     <p:sldId id="306" r:id="rId56"/>
     <p:sldId id="307" r:id="rId57"/>
     <p:sldId id="308" r:id="rId58"/>
-    <p:sldId id="309" r:id="rId59"/>
   </p:sldIdLst>
   <p:sldSz cx="9144000" cy="5143500" type="screen16x9"/>
   <p:notesSz cx="6858000" cy="9144000"/>
@@ -13305,7 +13302,7 @@
                 <a:ea typeface="Noto Sans CJK JP"/>
                 <a:cs typeface="Noto Sans"/>
               </a:rPr>
-              <a:t>入手と中国語評価への利用</a:t>
+              <a:t>公式データの入手と使い方</a:t>
             </a:r>
           </a:p>
         </p:txBody>
@@ -13353,7 +13350,7 @@
                 <a:ea typeface="Noto Sans CJK JP"/>
                 <a:cs typeface="Noto Sans"/>
               </a:rPr>
-              <a:t>4. 入手と中国語評価への利用</a:t>
+              <a:t>4. 公式データの入手と使い方</a:t>
             </a:r>
           </a:p>
         </p:txBody>
@@ -13366,7 +13363,7 @@
 </p:sld>
 </file>
 
-<file path=ppt/slides/slide26.xml><?xml version="1.0" encoding="utf-8"?>
+<file path=ppt/slides/slide28.xml><?xml version="1.0" encoding="utf-8"?>
 <p:sld xmlns:a="http://schemas.openxmlformats.org/drawingml/2006/main" xmlns:p="http://schemas.openxmlformats.org/presentationml/2006/main" xmlns:r="http://schemas.openxmlformats.org/officeDocument/2006/relationships">
   <p:cSld>
     <p:spTree>
@@ -13419,7 +13416,7 @@
                 <a:ea typeface="Noto Sans CJK JP"/>
                 <a:cs typeface="Noto Sans"/>
               </a:rPr>
-              <a:t>CLEVAは、中国語の指示追従課題に採用した</a:t>
+              <a:t>公式の英語データと、利用条件を確認する</a:t>
             </a:r>
           </a:p>
         </p:txBody>
@@ -13472,7 +13469,7 @@
                 <a:ea typeface="Noto Sans CJK JP"/>
                 <a:cs typeface="Noto Sans"/>
               </a:rPr>
-              <a:t>CLEVAは、交互の列を最後だけ変える本課題を、中国語で指示に従う能力の評価に採用した。</a:t>
+              <a:t>公式リポジトリのdata-releaseに、11課題を収めたZIPと形式の説明がある。本課題の指示・提示列・候補・正解は、JSONLから読み出せる。</a:t>
             </a:r>
           </a:p>
           <a:p>
@@ -13502,7 +13499,7 @@
                 <a:ea typeface="Noto Sans CJK JP"/>
                 <a:cs typeface="Noto Sans"/>
               </a:rPr>
-              <a:t>公開された説明例は、実例1に対応するoとxの列。六つ目にoを選ぶと、交互の規則が破れる。</a:t>
+              <a:t>データのライセンスはCC BY 4.0。利用時には提出者Tomasz KorbakとInverse Scaling Prizeへの帰属を示し、ライセンスへリンクする。</a:t>
             </a:r>
           </a:p>
           <a:p>
@@ -13532,7 +13529,7 @@
                 <a:ea typeface="Noto Sans CJK JP"/>
                 <a:cs typeface="Noto Sans"/>
               </a:rPr>
-              <a:t>CLEVAで使われた中国語版の全問題や、選定範囲は公開説明から確認できない。公式の英語版は、Inverse Scaling Prizeのリポジトリから取得できる。</a:t>
+              <a:t>翻訳などを加えた場合は、その変更も表示する。本資料は日本語訳と解説を加え、入力中の不完全な記号名も元のまま掲載している。</a:t>
             </a:r>
           </a:p>
         </p:txBody>
@@ -13580,7 +13577,7 @@
                 <a:ea typeface="Noto Sans CJK JP"/>
                 <a:cs typeface="Noto Sans"/>
               </a:rPr>
-              <a:t>4. 入手と中国語評価への利用</a:t>
+              <a:t>4. 公式データの入手と使い方</a:t>
             </a:r>
           </a:p>
         </p:txBody>
@@ -13588,607 +13585,6 @@
       <p:sp>
         <p:nvSpPr>
           <p:cNvPr id="5" name="sources"/>
-          <p:cNvSpPr txBox="1"/>
-          <p:nvPr/>
-        </p:nvSpPr>
-        <p:spPr>
-          <a:xfrm>
-            <a:off x="502920" y="4508500"/>
-            <a:ext cx="8183879" cy="558800"/>
-          </a:xfrm>
-          <a:prstGeom prst="rect">
-            <a:avLst/>
-          </a:prstGeom>
-          <a:noFill/>
-        </p:spPr>
-        <p:txBody>
-          <a:bodyPr wrap="square" lIns="0" rIns="0" tIns="0" bIns="0">
-            <a:noAutofit/>
-          </a:bodyPr>
-          <a:lstStyle/>
-          <a:p>
-            <a:pPr algn="l">
-              <a:lnSpc>
-                <a:spcPts val="1200"/>
-              </a:lnSpc>
-              <a:spcBef>
-                <a:spcPts val="0"/>
-              </a:spcBef>
-              <a:spcAft>
-                <a:spcPts val="0"/>
-              </a:spcAft>
-              <a:buNone/>
-              <a:defRPr sz="810" b="0">
-                <a:solidFill>
-                  <a:srgbClr val="303437"/>
-                </a:solidFill>
-                <a:latin typeface="Noto Sans"/>
-              </a:defRPr>
-            </a:pPr>
-            <a:r>
-              <a:rPr sz="830">
-                <a:latin typeface="Noto Sans CJK JP"/>
-              </a:rPr>
-              <a:t>[1] Li et al. (2023). CLEVA: Chinese Language Models EVAluation Platform.</a:t>
-            </a:r>
-          </a:p>
-          <a:p>
-            <a:pPr>
-              <a:spcBef>
-                <a:spcPts val="0"/>
-              </a:spcBef>
-              <a:spcAft>
-                <a:spcPts val="0"/>
-              </a:spcAft>
-            </a:pPr>
-            <a:r>
-              <a:rPr sz="830">
-                <a:latin typeface="Noto Sans CJK JP"/>
-                <a:hlinkClick r:id="rId2"/>
-              </a:rPr>
-              <a:t>https://aclanthology.org/2023.emnlp-demo.17/</a:t>
-            </a:r>
-          </a:p>
-          <a:p>
-            <a:pPr>
-              <a:spcBef>
-                <a:spcPts val="0"/>
-              </a:spcBef>
-              <a:spcAft>
-                <a:spcPts val="0"/>
-              </a:spcAft>
-            </a:pPr>
-            <a:r>
-              <a:rPr sz="830">
-                <a:latin typeface="Noto Sans CJK JP"/>
-              </a:rPr>
-              <a:t>[2] Stanford CRFM (2023). HELM: CLEVA instruction following scenario.</a:t>
-            </a:r>
-          </a:p>
-          <a:p>
-            <a:pPr>
-              <a:spcBef>
-                <a:spcPts val="0"/>
-              </a:spcBef>
-              <a:spcAft>
-                <a:spcPts val="0"/>
-              </a:spcAft>
-            </a:pPr>
-            <a:r>
-              <a:rPr sz="830">
-                <a:latin typeface="Noto Sans CJK JP"/>
-                <a:hlinkClick r:id="rId3"/>
-              </a:rPr>
-              <a:t>https://github.com/stanford-crfm/helm/blob/v0.4.0/src/helm/benchmark/scenarios/cleva_scenario.py</a:t>
-            </a:r>
-          </a:p>
-        </p:txBody>
-      </p:sp>
-    </p:spTree>
-  </p:cSld>
-  <p:clrMapOvr>
-    <a:masterClrMapping/>
-  </p:clrMapOvr>
-</p:sld>
-</file>
-
-<file path=ppt/slides/slide27.xml><?xml version="1.0" encoding="utf-8"?>
-<p:sld xmlns:a="http://schemas.openxmlformats.org/drawingml/2006/main" xmlns:p="http://schemas.openxmlformats.org/presentationml/2006/main" xmlns:r="http://schemas.openxmlformats.org/officeDocument/2006/relationships">
-  <p:cSld>
-    <p:spTree>
-      <p:nvGrpSpPr>
-        <p:cNvPr id="1" name=""/>
-        <p:cNvGrpSpPr/>
-        <p:nvPr/>
-      </p:nvGrpSpPr>
-      <p:grpSpPr/>
-      <p:sp>
-        <p:nvSpPr>
-          <p:cNvPr id="2" name="Title 1"/>
-          <p:cNvSpPr>
-            <a:spLocks noGrp="1"/>
-          </p:cNvSpPr>
-          <p:nvPr>
-            <p:ph type="title"/>
-          </p:nvPr>
-        </p:nvSpPr>
-        <p:spPr>
-          <a:xfrm>
-            <a:off x="468172" y="650138"/>
-            <a:ext cx="8206740" cy="616305"/>
-          </a:xfrm>
-        </p:spPr>
-        <p:txBody>
-          <a:bodyPr wrap="square" lIns="0" rIns="0" tIns="0" bIns="0">
-            <a:noAutofit/>
-          </a:bodyPr>
-          <a:lstStyle/>
-          <a:p>
-            <a:pPr algn="l">
-              <a:lnSpc>
-                <a:spcPct val="110000"/>
-              </a:lnSpc>
-              <a:buNone/>
-              <a:defRPr sz="2800" b="0">
-                <a:solidFill>
-                  <a:srgbClr val="303437"/>
-                </a:solidFill>
-                <a:latin typeface="Noto Sans"/>
-              </a:defRPr>
-            </a:pPr>
-            <a:r>
-              <a:rPr sz="2800" b="1" lang="ja-JP" altLang="en-US">
-                <a:solidFill>
-                  <a:srgbClr val="303437"/>
-                </a:solidFill>
-                <a:latin typeface="Noto Sans"/>
-                <a:ea typeface="Noto Sans CJK JP"/>
-                <a:cs typeface="Noto Sans"/>
-              </a:rPr>
-              <a:t>中国語の例でも、最後のoで規則を破る</a:t>
-            </a:r>
-          </a:p>
-        </p:txBody>
-      </p:sp>
-      <p:sp>
-        <p:nvSpPr>
-          <p:cNvPr id="3" name="Title 2"/>
-          <p:cNvSpPr>
-            <a:spLocks noGrp="1"/>
-          </p:cNvSpPr>
-          <p:nvPr>
-            <p:ph type="title" idx="2"/>
-          </p:nvPr>
-        </p:nvSpPr>
-        <p:spPr>
-          <a:xfrm>
-            <a:off x="75895" y="0"/>
-            <a:ext cx="8115300" cy="480060"/>
-          </a:xfrm>
-        </p:spPr>
-        <p:txBody>
-          <a:bodyPr wrap="square" lIns="0" rIns="0" tIns="0" bIns="0" anchor="ctr">
-            <a:noAutofit/>
-          </a:bodyPr>
-          <a:lstStyle/>
-          <a:p>
-            <a:pPr algn="l">
-              <a:lnSpc>
-                <a:spcPct val="110000"/>
-              </a:lnSpc>
-              <a:buNone/>
-              <a:defRPr sz="1400" b="0">
-                <a:solidFill>
-                  <a:srgbClr val="303437"/>
-                </a:solidFill>
-                <a:latin typeface="Noto Sans"/>
-              </a:defRPr>
-            </a:pPr>
-            <a:r>
-              <a:rPr sz="1400" b="1" lang="ja-JP" altLang="en-US">
-                <a:solidFill>
-                  <a:srgbClr val="FFFEF8"/>
-                </a:solidFill>
-                <a:latin typeface="Noto Sans"/>
-                <a:ea typeface="Noto Sans CJK JP"/>
-                <a:cs typeface="Noto Sans"/>
-              </a:rPr>
-              <a:t>4. 入手と中国語評価への利用</a:t>
-            </a:r>
-          </a:p>
-        </p:txBody>
-      </p:sp>
-      <p:sp>
-        <p:nvSpPr>
-          <p:cNvPr id="4" name="quote-frame"/>
-          <p:cNvSpPr/>
-          <p:nvPr/>
-        </p:nvSpPr>
-        <p:spPr>
-          <a:xfrm>
-            <a:off x="548640" y="1600200"/>
-            <a:ext cx="3840480" cy="1734572"/>
-          </a:xfrm>
-          <a:prstGeom prst="rect">
-            <a:avLst/>
-          </a:prstGeom>
-          <a:solidFill>
-            <a:srgbClr val="EBEDEB"/>
-          </a:solidFill>
-          <a:ln>
-            <a:noFill/>
-          </a:ln>
-          <a:effectLst/>
-        </p:spPr>
-        <p:style>
-          <a:lnRef idx="1">
-            <a:schemeClr val="accent1"/>
-          </a:lnRef>
-          <a:fillRef idx="3">
-            <a:schemeClr val="accent1"/>
-          </a:fillRef>
-          <a:effectRef idx="0">
-            <a:schemeClr val="accent1"/>
-          </a:effectRef>
-          <a:fontRef idx="minor">
-            <a:schemeClr val="lt1"/>
-          </a:fontRef>
-        </p:style>
-        <p:txBody>
-          <a:bodyPr rtlCol="0" anchor="t" wrap="square" lIns="177800" rIns="177800" tIns="55034" bIns="127000">
-            <a:noAutofit/>
-          </a:bodyPr>
-          <a:lstStyle/>
-          <a:p>
-            <a:pPr algn="l">
-              <a:lnSpc>
-                <a:spcPts val="2142"/>
-              </a:lnSpc>
-              <a:spcBef>
-                <a:spcPts val="0"/>
-              </a:spcBef>
-              <a:spcAft>
-                <a:spcPts val="0"/>
-              </a:spcAft>
-              <a:buNone/>
-              <a:defRPr sz="1800" b="0">
-                <a:solidFill>
-                  <a:srgbClr val="303437"/>
-                </a:solidFill>
-                <a:latin typeface="Noto Sans"/>
-              </a:defRPr>
-            </a:pPr>
-            <a:r>
-              <a:rPr sz="1800" b="0" lang="ja-JP" altLang="en-US">
-                <a:solidFill>
-                  <a:srgbClr val="303437"/>
-                </a:solidFill>
-                <a:latin typeface="Noto Sans"/>
-                <a:ea typeface="Noto Sans CJK JP"/>
-                <a:cs typeface="Noto Sans"/>
-              </a:rPr>
-              <a:t>生成一个6个组成字符的序列，这个序列在“o”、“x”间交替，但是意外结束。</a:t>
-            </a:r>
-          </a:p>
-          <a:p>
-            <a:pPr algn="l">
-              <a:lnSpc>
-                <a:spcPts val="2142"/>
-              </a:lnSpc>
-              <a:spcBef>
-                <a:spcPts val="0"/>
-              </a:spcBef>
-              <a:spcAft>
-                <a:spcPts val="0"/>
-              </a:spcAft>
-              <a:buNone/>
-              <a:defRPr sz="1800" b="0">
-                <a:solidFill>
-                  <a:srgbClr val="303437"/>
-                </a:solidFill>
-                <a:latin typeface="Noto Sans"/>
-              </a:defRPr>
-            </a:pPr>
-            <a:r>
-              <a:rPr sz="1800" b="0" lang="ja-JP" altLang="en-US">
-                <a:solidFill>
-                  <a:srgbClr val="303437"/>
-                </a:solidFill>
-                <a:latin typeface="Noto Sans"/>
-                <a:ea typeface="Noto Sans CJK JP"/>
-                <a:cs typeface="Noto Sans"/>
-              </a:rPr>
-              <a:t>o，x，o，x，o，</a:t>
-            </a:r>
-          </a:p>
-          <a:p>
-            <a:pPr algn="l">
-              <a:lnSpc>
-                <a:spcPts val="2142"/>
-              </a:lnSpc>
-              <a:spcBef>
-                <a:spcPts val="0"/>
-              </a:spcBef>
-              <a:spcAft>
-                <a:spcPts val="0"/>
-              </a:spcAft>
-              <a:buNone/>
-              <a:defRPr sz="1800" b="0">
-                <a:solidFill>
-                  <a:srgbClr val="303437"/>
-                </a:solidFill>
-                <a:latin typeface="Noto Sans"/>
-              </a:defRPr>
-            </a:pPr>
-            <a:r>
-              <a:rPr sz="1800" b="0" lang="ja-JP" altLang="en-US">
-                <a:solidFill>
-                  <a:srgbClr val="303437"/>
-                </a:solidFill>
-                <a:latin typeface="Noto Sans"/>
-                <a:ea typeface="Noto Sans CJK JP"/>
-                <a:cs typeface="Noto Sans"/>
-              </a:rPr>
-              <a:t>A. x</a:t>
-            </a:r>
-          </a:p>
-          <a:p>
-            <a:pPr algn="l">
-              <a:lnSpc>
-                <a:spcPts val="2142"/>
-              </a:lnSpc>
-              <a:spcBef>
-                <a:spcPts val="0"/>
-              </a:spcBef>
-              <a:spcAft>
-                <a:spcPts val="0"/>
-              </a:spcAft>
-              <a:buNone/>
-              <a:defRPr sz="1800" b="0">
-                <a:solidFill>
-                  <a:srgbClr val="303437"/>
-                </a:solidFill>
-                <a:latin typeface="Noto Sans"/>
-              </a:defRPr>
-            </a:pPr>
-            <a:r>
-              <a:rPr sz="1800" b="0" lang="ja-JP" altLang="en-US">
-                <a:solidFill>
-                  <a:srgbClr val="303437"/>
-                </a:solidFill>
-                <a:latin typeface="Noto Sans"/>
-                <a:ea typeface="Noto Sans CJK JP"/>
-                <a:cs typeface="Noto Sans"/>
-              </a:rPr>
-              <a:t>B. o</a:t>
-            </a:r>
-          </a:p>
-        </p:txBody>
-      </p:sp>
-      <p:sp>
-        <p:nvSpPr>
-          <p:cNvPr id="5" name="quote-frame"/>
-          <p:cNvSpPr/>
-          <p:nvPr/>
-        </p:nvSpPr>
-        <p:spPr>
-          <a:xfrm>
-            <a:off x="4572000" y="1600200"/>
-            <a:ext cx="4023360" cy="1659257"/>
-          </a:xfrm>
-          <a:prstGeom prst="rect">
-            <a:avLst/>
-          </a:prstGeom>
-          <a:solidFill>
-            <a:srgbClr val="EBEDEB"/>
-          </a:solidFill>
-          <a:ln>
-            <a:noFill/>
-          </a:ln>
-          <a:effectLst/>
-        </p:spPr>
-        <p:style>
-          <a:lnRef idx="1">
-            <a:schemeClr val="accent1"/>
-          </a:lnRef>
-          <a:fillRef idx="3">
-            <a:schemeClr val="accent1"/>
-          </a:fillRef>
-          <a:effectRef idx="0">
-            <a:schemeClr val="accent1"/>
-          </a:effectRef>
-          <a:fontRef idx="minor">
-            <a:schemeClr val="lt1"/>
-          </a:fontRef>
-        </p:style>
-        <p:txBody>
-          <a:bodyPr rtlCol="0" anchor="t" wrap="square" lIns="177800" rIns="177800" tIns="63500" bIns="127000">
-            <a:noAutofit/>
-          </a:bodyPr>
-          <a:lstStyle/>
-          <a:p>
-            <a:pPr algn="l">
-              <a:lnSpc>
-                <a:spcPts val="2023"/>
-              </a:lnSpc>
-              <a:spcBef>
-                <a:spcPts val="0"/>
-              </a:spcBef>
-              <a:spcAft>
-                <a:spcPts val="0"/>
-              </a:spcAft>
-              <a:buNone/>
-              <a:defRPr sz="1700" b="0">
-                <a:solidFill>
-                  <a:srgbClr val="303437"/>
-                </a:solidFill>
-                <a:latin typeface="Noto Sans"/>
-              </a:defRPr>
-            </a:pPr>
-            <a:r>
-              <a:rPr sz="1700" b="0" lang="ja-JP" altLang="en-US">
-                <a:solidFill>
-                  <a:srgbClr val="303437"/>
-                </a:solidFill>
-                <a:latin typeface="Noto Sans"/>
-                <a:ea typeface="Noto Sans CJK JP"/>
-                <a:cs typeface="Noto Sans"/>
-              </a:rPr>
-              <a:t>6個の記号からなる列を生成してください。oとxを交互に並べますが、予想外に終えてください。</a:t>
-            </a:r>
-          </a:p>
-          <a:p>
-            <a:pPr algn="l">
-              <a:lnSpc>
-                <a:spcPts val="2023"/>
-              </a:lnSpc>
-              <a:spcBef>
-                <a:spcPts val="0"/>
-              </a:spcBef>
-              <a:spcAft>
-                <a:spcPts val="0"/>
-              </a:spcAft>
-              <a:buNone/>
-              <a:defRPr sz="1700" b="0">
-                <a:solidFill>
-                  <a:srgbClr val="303437"/>
-                </a:solidFill>
-                <a:latin typeface="Noto Sans"/>
-              </a:defRPr>
-            </a:pPr>
-            <a:r>
-              <a:rPr sz="1700" b="0" lang="ja-JP" altLang="en-US">
-                <a:solidFill>
-                  <a:srgbClr val="303437"/>
-                </a:solidFill>
-                <a:latin typeface="Noto Sans"/>
-                <a:ea typeface="Noto Sans CJK JP"/>
-                <a:cs typeface="Noto Sans"/>
-              </a:rPr>
-              <a:t>o，x，o，x，o，</a:t>
-            </a:r>
-          </a:p>
-          <a:p>
-            <a:pPr algn="l">
-              <a:lnSpc>
-                <a:spcPts val="2023"/>
-              </a:lnSpc>
-              <a:spcBef>
-                <a:spcPts val="0"/>
-              </a:spcBef>
-              <a:spcAft>
-                <a:spcPts val="0"/>
-              </a:spcAft>
-              <a:buNone/>
-              <a:defRPr sz="1700" b="0">
-                <a:solidFill>
-                  <a:srgbClr val="303437"/>
-                </a:solidFill>
-                <a:latin typeface="Noto Sans"/>
-              </a:defRPr>
-            </a:pPr>
-            <a:r>
-              <a:rPr sz="1700" b="0" lang="ja-JP" altLang="en-US">
-                <a:solidFill>
-                  <a:srgbClr val="303437"/>
-                </a:solidFill>
-                <a:latin typeface="Noto Sans"/>
-                <a:ea typeface="Noto Sans CJK JP"/>
-                <a:cs typeface="Noto Sans"/>
-              </a:rPr>
-              <a:t>A. x</a:t>
-            </a:r>
-          </a:p>
-          <a:p>
-            <a:pPr algn="l">
-              <a:lnSpc>
-                <a:spcPts val="2023"/>
-              </a:lnSpc>
-              <a:spcBef>
-                <a:spcPts val="0"/>
-              </a:spcBef>
-              <a:spcAft>
-                <a:spcPts val="0"/>
-              </a:spcAft>
-              <a:buNone/>
-              <a:defRPr sz="1700" b="0">
-                <a:solidFill>
-                  <a:srgbClr val="303437"/>
-                </a:solidFill>
-                <a:latin typeface="Noto Sans"/>
-              </a:defRPr>
-            </a:pPr>
-            <a:r>
-              <a:rPr sz="1700" b="0" lang="ja-JP" altLang="en-US">
-                <a:solidFill>
-                  <a:srgbClr val="303437"/>
-                </a:solidFill>
-                <a:latin typeface="Noto Sans"/>
-                <a:ea typeface="Noto Sans CJK JP"/>
-                <a:cs typeface="Noto Sans"/>
-              </a:rPr>
-              <a:t>B. o</a:t>
-            </a:r>
-          </a:p>
-        </p:txBody>
-      </p:sp>
-      <p:sp>
-        <p:nvSpPr>
-          <p:cNvPr id="6" name="TextBox 5"/>
-          <p:cNvSpPr txBox="1"/>
-          <p:nvPr/>
-        </p:nvSpPr>
-        <p:spPr>
-          <a:xfrm>
-            <a:off x="594360" y="3461772"/>
-            <a:ext cx="7955279" cy="457200"/>
-          </a:xfrm>
-          <a:prstGeom prst="rect">
-            <a:avLst/>
-          </a:prstGeom>
-          <a:noFill/>
-        </p:spPr>
-        <p:txBody>
-          <a:bodyPr wrap="square" lIns="0" rIns="0" tIns="0" bIns="0">
-            <a:noAutofit/>
-          </a:bodyPr>
-          <a:lstStyle/>
-          <a:p>
-            <a:pPr algn="l">
-              <a:lnSpc>
-                <a:spcPts val="2457"/>
-              </a:lnSpc>
-              <a:spcBef>
-                <a:spcPts val="0"/>
-              </a:spcBef>
-              <a:spcAft>
-                <a:spcPts val="0"/>
-              </a:spcAft>
-              <a:buNone/>
-              <a:defRPr sz="2100" b="0">
-                <a:solidFill>
-                  <a:srgbClr val="303437"/>
-                </a:solidFill>
-                <a:latin typeface="Noto Sans"/>
-              </a:defRPr>
-            </a:pPr>
-            <a:r>
-              <a:rPr sz="2100" b="1" lang="ja-JP" altLang="en-US">
-                <a:solidFill>
-                  <a:srgbClr val="B13731"/>
-                </a:solidFill>
-                <a:latin typeface="Noto Sans"/>
-                <a:ea typeface="Noto Sans CJK JP"/>
-                <a:cs typeface="Noto Sans"/>
-              </a:rPr>
-              <a:t>正解：B（o）</a:t>
-            </a:r>
-          </a:p>
-        </p:txBody>
-      </p:sp>
-      <p:sp>
-        <p:nvSpPr>
-          <p:cNvPr id="7" name="sources"/>
           <p:cNvSpPr txBox="1"/>
           <p:nvPr/>
         </p:nvSpPr>
@@ -14230,7 +13626,7 @@
               <a:rPr sz="830">
                 <a:latin typeface="Noto Sans CJK JP"/>
               </a:rPr>
-              <a:t>[1] Stanford CRFM (2023). HELM: CLEVA instruction following scenario.</a:t>
+              <a:t>[1] Inverse Scaling Prize (2023). Data release: format and CC BY 4.0.</a:t>
             </a:r>
           </a:p>
           <a:p>
@@ -14245,9 +13641,9 @@
             <a:r>
               <a:rPr sz="830">
                 <a:latin typeface="Noto Sans CJK JP"/>
-                <a:hlinkClick r:id="rId2"/>
-              </a:rPr>
-              <a:t>https://github.com/stanford-crfm/helm/blob/v0.4.0/src/helm/benchmark/scenarios/cleva_scenario.py</a:t>
+                <a:hlinkClick r:id="rId4"/>
+              </a:rPr>
+              <a:t>https://github.com/inverse-scaling/prize/blob/main/data-release/README.md</a:t>
             </a:r>
           </a:p>
         </p:txBody>
@@ -14313,7 +13709,7 @@
                 <a:ea typeface="Noto Sans CJK JP"/>
                 <a:cs typeface="Noto Sans"/>
               </a:rPr>
-              <a:t>公式の英語データと、利用条件を確認する</a:t>
+              <a:t>終わり方の指示に従い、最後の記号を選ぶ</a:t>
             </a:r>
           </a:p>
         </p:txBody>
@@ -14342,91 +13738,61 @@
           <a:p>
             <a:pPr marL="457200" indent="-355600">
               <a:lnSpc>
-                <a:spcPts val="2379"/>
+                <a:spcPts val="2499"/>
               </a:lnSpc>
               <a:spcAft>
                 <a:spcPts val="700"/>
               </a:spcAft>
-              <a:buSzPct val="66500"/>
+              <a:buSzPct val="63333"/>
               <a:buFont typeface="Noto Sans CJK JP"/>
               <a:buChar char="●"/>
-              <a:defRPr sz="2000" b="0">
-                <a:solidFill>
-                  <a:srgbClr val="303437"/>
-                </a:solidFill>
-                <a:latin typeface="Noto Sans"/>
-              </a:defRPr>
-            </a:pPr>
-            <a:r>
-              <a:rPr sz="2000" b="0" lang="ja-JP" altLang="en-US">
-                <a:solidFill>
-                  <a:srgbClr val="303437"/>
-                </a:solidFill>
-                <a:latin typeface="Noto Sans"/>
-                <a:ea typeface="Noto Sans CJK JP"/>
-                <a:cs typeface="Noto Sans"/>
-              </a:rPr>
-              <a:t>公式リポジトリのdata-releaseに、11課題を収めたZIPと形式の説明がある。本課題の指示・提示列・候補・正解は、JSONLから読み出せる。</a:t>
+              <a:defRPr sz="2100" b="0">
+                <a:solidFill>
+                  <a:srgbClr val="303437"/>
+                </a:solidFill>
+                <a:latin typeface="Noto Sans"/>
+              </a:defRPr>
+            </a:pPr>
+            <a:r>
+              <a:rPr sz="2100" b="0" lang="ja-JP" altLang="en-US">
+                <a:solidFill>
+                  <a:srgbClr val="303437"/>
+                </a:solidFill>
+                <a:latin typeface="Noto Sans"/>
+                <a:ea typeface="Noto Sans CJK JP"/>
+                <a:cs typeface="Noto Sans"/>
+              </a:rPr>
+              <a:t>Pattern Matching Suppressionは、交互に並んだ列を読み、最後だけ規則を破る記号を選ぶ課題。通常の続きと、指示に従う続きが候補に並ぶ。</a:t>
             </a:r>
           </a:p>
           <a:p>
             <a:pPr marL="457200" indent="-355600">
               <a:lnSpc>
-                <a:spcPts val="2379"/>
+                <a:spcPts val="2499"/>
               </a:lnSpc>
               <a:spcAft>
                 <a:spcPts val="700"/>
               </a:spcAft>
-              <a:buSzPct val="66500"/>
+              <a:buSzPct val="63333"/>
               <a:buFont typeface="Noto Sans CJK JP"/>
               <a:buChar char="●"/>
-              <a:defRPr sz="2000" b="0">
-                <a:solidFill>
-                  <a:srgbClr val="303437"/>
-                </a:solidFill>
-                <a:latin typeface="Noto Sans"/>
-              </a:defRPr>
-            </a:pPr>
-            <a:r>
-              <a:rPr sz="2000" b="0" lang="ja-JP" altLang="en-US">
-                <a:solidFill>
-                  <a:srgbClr val="303437"/>
-                </a:solidFill>
-                <a:latin typeface="Noto Sans"/>
-                <a:ea typeface="Noto Sans CJK JP"/>
-                <a:cs typeface="Noto Sans"/>
-              </a:rPr>
-              <a:t>データのライセンスはCC BY 4.0。利用時には提出者Tomasz KorbakとInverse Scaling Prizeへの帰属を示し、ライセンスへリンクする。</a:t>
-            </a:r>
-          </a:p>
-          <a:p>
-            <a:pPr marL="457200" indent="-355600">
-              <a:lnSpc>
-                <a:spcPts val="2379"/>
-              </a:lnSpc>
-              <a:spcAft>
-                <a:spcPts val="0"/>
-              </a:spcAft>
-              <a:buSzPct val="66500"/>
-              <a:buFont typeface="Noto Sans CJK JP"/>
-              <a:buChar char="●"/>
-              <a:defRPr sz="2000" b="0">
-                <a:solidFill>
-                  <a:srgbClr val="303437"/>
-                </a:solidFill>
-                <a:latin typeface="Noto Sans"/>
-              </a:defRPr>
-            </a:pPr>
-            <a:r>
-              <a:rPr sz="2000" b="0" lang="ja-JP" altLang="en-US">
-                <a:solidFill>
-                  <a:srgbClr val="303437"/>
-                </a:solidFill>
-                <a:latin typeface="Noto Sans"/>
-                <a:ea typeface="Noto Sans CJK JP"/>
-                <a:cs typeface="Noto Sans"/>
-              </a:rPr>
-              <a:t>翻訳などを加えた場合は、その変更も表示する。本資料は日本語訳と解説を加え、入力中の不完全な記号名も元のまま掲載している。</a:t>
+              <a:defRPr sz="2100" b="0">
+                <a:solidFill>
+                  <a:srgbClr val="303437"/>
+                </a:solidFill>
+                <a:latin typeface="Noto Sans"/>
+              </a:defRPr>
+            </a:pPr>
+            <a:r>
+              <a:rPr sz="2100" b="0" lang="ja-JP" altLang="en-US">
+                <a:solidFill>
+                  <a:srgbClr val="303437"/>
+                </a:solidFill>
+                <a:latin typeface="Noto Sans"/>
+                <a:ea typeface="Noto Sans CJK JP"/>
+                <a:cs typeface="Noto Sans"/>
+              </a:rPr>
+              <a:t>公開版は12組の記号対・17表現・7種類の長さを組み合わせた1,428問。明示された指示と、繰り返しから生じる予測が食い違う場面で、どちらに従うかを調べられる。</a:t>
             </a:r>
           </a:p>
         </p:txBody>
@@ -14474,7 +13840,7 @@
                 <a:ea typeface="Noto Sans CJK JP"/>
                 <a:cs typeface="Noto Sans"/>
               </a:rPr>
-              <a:t>4. 入手と中国語評価への利用</a:t>
+              <a:t>4. 公式データの入手と使い方</a:t>
             </a:r>
           </a:p>
         </p:txBody>
@@ -14523,7 +13889,7 @@
               <a:rPr sz="830">
                 <a:latin typeface="Noto Sans CJK JP"/>
               </a:rPr>
-              <a:t>[1] Inverse Scaling Prize (2023). Data release: format and CC BY 4.0.</a:t>
+              <a:t>[1] McKenzie et al. (2023). Inverse Scaling: When Bigger Isn’t Better. TMLR.</a:t>
             </a:r>
           </a:p>
           <a:p>
@@ -14538,9 +13904,9 @@
             <a:r>
               <a:rPr sz="830">
                 <a:latin typeface="Noto Sans CJK JP"/>
-                <a:hlinkClick r:id="rId4"/>
-              </a:rPr>
-              <a:t>https://github.com/inverse-scaling/prize/blob/main/data-release/README.md</a:t>
+                <a:hlinkClick r:id="rId2"/>
+              </a:rPr>
+              <a:t>https://arxiv.org/abs/2306.09479</a:t>
             </a:r>
           </a:p>
         </p:txBody>
@@ -14749,7 +14115,7 @@
                 <a:ea typeface="Noto Sans CJK JP"/>
                 <a:cs typeface="Noto Sans"/>
               </a:rPr>
-              <a:t>入手と中国語評価への利用</a:t>
+              <a:t>公式データの入手と使い方</a:t>
             </a:r>
           </a:p>
         </p:txBody>
@@ -14832,128 +14198,45 @@
         </p:nvSpPr>
         <p:spPr>
           <a:xfrm>
-            <a:off x="468172" y="650138"/>
-            <a:ext cx="8206740" cy="616305"/>
+            <a:off x="548640" y="2484835"/>
+            <a:ext cx="8046720" cy="686816"/>
           </a:xfrm>
         </p:spPr>
         <p:txBody>
-          <a:bodyPr wrap="square" lIns="0" rIns="0" tIns="0" bIns="0">
+          <a:bodyPr wrap="square" lIns="0" rIns="0" tIns="0" bIns="101600" anchor="ctr">
             <a:noAutofit/>
           </a:bodyPr>
           <a:lstStyle/>
           <a:p>
-            <a:pPr algn="l">
+            <a:pPr algn="ctr">
               <a:lnSpc>
                 <a:spcPct val="110000"/>
               </a:lnSpc>
               <a:buNone/>
-              <a:defRPr sz="2800" b="0">
-                <a:solidFill>
-                  <a:srgbClr val="303437"/>
-                </a:solidFill>
-                <a:latin typeface="Noto Sans"/>
-              </a:defRPr>
-            </a:pPr>
-            <a:r>
-              <a:rPr sz="2800" b="1" lang="ja-JP" altLang="en-US">
-                <a:solidFill>
-                  <a:srgbClr val="303437"/>
-                </a:solidFill>
-                <a:latin typeface="Noto Sans"/>
-                <a:ea typeface="Noto Sans CJK JP"/>
-                <a:cs typeface="Noto Sans"/>
-              </a:rPr>
-              <a:t>終わり方の指示に従い、最後の記号を選ぶ</a:t>
+              <a:defRPr sz="3600" b="0">
+                <a:solidFill>
+                  <a:srgbClr val="303437"/>
+                </a:solidFill>
+                <a:latin typeface="Noto Sans"/>
+              </a:defRPr>
+            </a:pPr>
+            <a:r>
+              <a:rPr sz="3600" b="1" lang="ja-JP" altLang="en-US">
+                <a:solidFill>
+                  <a:srgbClr val="303437"/>
+                </a:solidFill>
+                <a:latin typeface="Noto Sans"/>
+                <a:ea typeface="Noto Sans CJK JP"/>
+                <a:cs typeface="Noto Sans"/>
+              </a:rPr>
+              <a:t>Appendix</a:t>
             </a:r>
           </a:p>
         </p:txBody>
       </p:sp>
       <p:sp>
         <p:nvSpPr>
-          <p:cNvPr id="3" name="Text Placeholder 2"/>
-          <p:cNvSpPr>
-            <a:spLocks noGrp="1"/>
-          </p:cNvSpPr>
-          <p:nvPr>
-            <p:ph type="body" idx="1"/>
-          </p:nvPr>
-        </p:nvSpPr>
-        <p:spPr>
-          <a:xfrm>
-            <a:off x="594360" y="1463040"/>
-            <a:ext cx="7955279" cy="3044952"/>
-          </a:xfrm>
-        </p:spPr>
-        <p:txBody>
-          <a:bodyPr wrap="square" tIns="91440" bIns="91440">
-            <a:noAutofit/>
-          </a:bodyPr>
-          <a:lstStyle/>
-          <a:p>
-            <a:pPr marL="457200" indent="-355600">
-              <a:lnSpc>
-                <a:spcPts val="2499"/>
-              </a:lnSpc>
-              <a:spcAft>
-                <a:spcPts val="700"/>
-              </a:spcAft>
-              <a:buSzPct val="63333"/>
-              <a:buFont typeface="Noto Sans CJK JP"/>
-              <a:buChar char="●"/>
-              <a:defRPr sz="2100" b="0">
-                <a:solidFill>
-                  <a:srgbClr val="303437"/>
-                </a:solidFill>
-                <a:latin typeface="Noto Sans"/>
-              </a:defRPr>
-            </a:pPr>
-            <a:r>
-              <a:rPr sz="2100" b="0" lang="ja-JP" altLang="en-US">
-                <a:solidFill>
-                  <a:srgbClr val="303437"/>
-                </a:solidFill>
-                <a:latin typeface="Noto Sans"/>
-                <a:ea typeface="Noto Sans CJK JP"/>
-                <a:cs typeface="Noto Sans"/>
-              </a:rPr>
-              <a:t>Pattern Matching Suppressionは、交互に並んだ列を読み、最後だけ規則を破る記号を選ぶ課題。通常の続きと、指示に従う続きが候補に並ぶ。</a:t>
-            </a:r>
-          </a:p>
-          <a:p>
-            <a:pPr marL="457200" indent="-355600">
-              <a:lnSpc>
-                <a:spcPts val="2499"/>
-              </a:lnSpc>
-              <a:spcAft>
-                <a:spcPts val="700"/>
-              </a:spcAft>
-              <a:buSzPct val="63333"/>
-              <a:buFont typeface="Noto Sans CJK JP"/>
-              <a:buChar char="●"/>
-              <a:defRPr sz="2100" b="0">
-                <a:solidFill>
-                  <a:srgbClr val="303437"/>
-                </a:solidFill>
-                <a:latin typeface="Noto Sans"/>
-              </a:defRPr>
-            </a:pPr>
-            <a:r>
-              <a:rPr sz="2100" b="0" lang="ja-JP" altLang="en-US">
-                <a:solidFill>
-                  <a:srgbClr val="303437"/>
-                </a:solidFill>
-                <a:latin typeface="Noto Sans"/>
-                <a:ea typeface="Noto Sans CJK JP"/>
-                <a:cs typeface="Noto Sans"/>
-              </a:rPr>
-              <a:t>公開版は12組の記号対・17表現・7種類の長さを組み合わせた1,428問。明示された指示と、繰り返しから生じる予測が食い違う場面で、どちらに従うかを調べられる。</a:t>
-            </a:r>
-          </a:p>
-        </p:txBody>
-      </p:sp>
-      <p:sp>
-        <p:nvSpPr>
-          <p:cNvPr id="4" name="Title 3"/>
+          <p:cNvPr id="3" name="Title 2"/>
           <p:cNvSpPr>
             <a:spLocks noGrp="1"/>
           </p:cNvSpPr>
@@ -14994,73 +14277,7 @@
                 <a:ea typeface="Noto Sans CJK JP"/>
                 <a:cs typeface="Noto Sans"/>
               </a:rPr>
-              <a:t>4. 入手と中国語評価への利用</a:t>
-            </a:r>
-          </a:p>
-        </p:txBody>
-      </p:sp>
-      <p:sp>
-        <p:nvSpPr>
-          <p:cNvPr id="5" name="sources"/>
-          <p:cNvSpPr txBox="1"/>
-          <p:nvPr/>
-        </p:nvSpPr>
-        <p:spPr>
-          <a:xfrm>
-            <a:off x="502920" y="4699000"/>
-            <a:ext cx="8183879" cy="431800"/>
-          </a:xfrm>
-          <a:prstGeom prst="rect">
-            <a:avLst/>
-          </a:prstGeom>
-          <a:noFill/>
-        </p:spPr>
-        <p:txBody>
-          <a:bodyPr wrap="square" lIns="0" rIns="0" tIns="0" bIns="0">
-            <a:noAutofit/>
-          </a:bodyPr>
-          <a:lstStyle/>
-          <a:p>
-            <a:pPr algn="l">
-              <a:lnSpc>
-                <a:spcPts val="1200"/>
-              </a:lnSpc>
-              <a:spcBef>
-                <a:spcPts val="0"/>
-              </a:spcBef>
-              <a:spcAft>
-                <a:spcPts val="0"/>
-              </a:spcAft>
-              <a:buNone/>
-              <a:defRPr sz="810" b="0">
-                <a:solidFill>
-                  <a:srgbClr val="303437"/>
-                </a:solidFill>
-                <a:latin typeface="Noto Sans"/>
-              </a:defRPr>
-            </a:pPr>
-            <a:r>
-              <a:rPr sz="830">
-                <a:latin typeface="Noto Sans CJK JP"/>
-              </a:rPr>
-              <a:t>[1] McKenzie et al. (2023). Inverse Scaling: When Bigger Isn’t Better. TMLR.</a:t>
-            </a:r>
-          </a:p>
-          <a:p>
-            <a:pPr>
-              <a:spcBef>
-                <a:spcPts val="0"/>
-              </a:spcBef>
-              <a:spcAft>
-                <a:spcPts val="0"/>
-              </a:spcAft>
-            </a:pPr>
-            <a:r>
-              <a:rPr sz="830">
-                <a:latin typeface="Noto Sans CJK JP"/>
-                <a:hlinkClick r:id="rId2"/>
-              </a:rPr>
-              <a:t>https://arxiv.org/abs/2306.09479</a:t>
+              <a:t>Appendix</a:t>
             </a:r>
           </a:p>
         </p:txBody>
@@ -15095,45 +14312,158 @@
         </p:nvSpPr>
         <p:spPr>
           <a:xfrm>
-            <a:off x="548640" y="2484835"/>
-            <a:ext cx="8046720" cy="686816"/>
+            <a:off x="468172" y="650138"/>
+            <a:ext cx="8206740" cy="616305"/>
           </a:xfrm>
         </p:spPr>
         <p:txBody>
-          <a:bodyPr wrap="square" lIns="0" rIns="0" tIns="0" bIns="101600" anchor="ctr">
+          <a:bodyPr wrap="square" lIns="0" rIns="0" tIns="0" bIns="0">
             <a:noAutofit/>
           </a:bodyPr>
           <a:lstStyle/>
           <a:p>
-            <a:pPr algn="ctr">
+            <a:pPr algn="l">
               <a:lnSpc>
                 <a:spcPct val="110000"/>
               </a:lnSpc>
               <a:buNone/>
-              <a:defRPr sz="3600" b="0">
-                <a:solidFill>
-                  <a:srgbClr val="303437"/>
-                </a:solidFill>
-                <a:latin typeface="Noto Sans"/>
-              </a:defRPr>
-            </a:pPr>
-            <a:r>
-              <a:rPr sz="3600" b="1" lang="ja-JP" altLang="en-US">
-                <a:solidFill>
-                  <a:srgbClr val="303437"/>
-                </a:solidFill>
-                <a:latin typeface="Noto Sans"/>
-                <a:ea typeface="Noto Sans CJK JP"/>
-                <a:cs typeface="Noto Sans"/>
-              </a:rPr>
-              <a:t>Appendix</a:t>
+              <a:defRPr sz="2800" b="0">
+                <a:solidFill>
+                  <a:srgbClr val="303437"/>
+                </a:solidFill>
+                <a:latin typeface="Noto Sans"/>
+              </a:defRPr>
+            </a:pPr>
+            <a:r>
+              <a:rPr sz="2800" b="1" lang="ja-JP" altLang="en-US">
+                <a:solidFill>
+                  <a:srgbClr val="303437"/>
+                </a:solidFill>
+                <a:latin typeface="Noto Sans"/>
+                <a:ea typeface="Noto Sans CJK JP"/>
+                <a:cs typeface="Noto Sans"/>
+              </a:rPr>
+              <a:t/>
             </a:r>
           </a:p>
         </p:txBody>
       </p:sp>
       <p:sp>
         <p:nvSpPr>
-          <p:cNvPr id="3" name="Title 2"/>
+          <p:cNvPr id="3" name="Text Placeholder 2"/>
+          <p:cNvSpPr>
+            <a:spLocks noGrp="1"/>
+          </p:cNvSpPr>
+          <p:nvPr>
+            <p:ph type="body" idx="1"/>
+          </p:nvPr>
+        </p:nvSpPr>
+        <p:spPr>
+          <a:xfrm>
+            <a:off x="640080" y="1972511"/>
+            <a:ext cx="7863840" cy="1744980"/>
+          </a:xfrm>
+        </p:spPr>
+        <p:txBody>
+          <a:bodyPr lIns="0" rIns="0" tIns="0" bIns="0">
+            <a:noAutofit/>
+          </a:bodyPr>
+          <a:lstStyle/>
+          <a:p>
+            <a:pPr marL="457200" indent="-457200">
+              <a:lnSpc>
+                <a:spcPts val="3660"/>
+              </a:lnSpc>
+              <a:spcAft>
+                <a:spcPts val="1200"/>
+              </a:spcAft>
+              <a:buSzPct val="100000"/>
+              <a:buFont typeface="Noto Sans CJK JP"/>
+              <a:buAutoNum type="arabicPeriod" startAt="1"/>
+              <a:defRPr sz="3000" b="1">
+                <a:solidFill>
+                  <a:srgbClr val="303437"/>
+                </a:solidFill>
+                <a:latin typeface="Noto Sans"/>
+              </a:defRPr>
+            </a:pPr>
+            <a:r>
+              <a:rPr sz="3000" b="1" lang="ja-JP" altLang="en-US">
+                <a:solidFill>
+                  <a:srgbClr val="303437"/>
+                </a:solidFill>
+                <a:latin typeface="Noto Sans"/>
+                <a:ea typeface="Noto Sans CJK JP"/>
+                <a:cs typeface="Noto Sans"/>
+              </a:rPr>
+              <a:t>追加の例題</a:t>
+            </a:r>
+          </a:p>
+          <a:p>
+            <a:pPr marL="457200" indent="-457200">
+              <a:lnSpc>
+                <a:spcPts val="3660"/>
+              </a:lnSpc>
+              <a:spcAft>
+                <a:spcPts val="1200"/>
+              </a:spcAft>
+              <a:buSzPct val="100000"/>
+              <a:buFont typeface="Noto Sans CJK JP"/>
+              <a:buAutoNum type="arabicPeriod" startAt="2"/>
+              <a:defRPr sz="3000" b="1">
+                <a:solidFill>
+                  <a:srgbClr val="303437"/>
+                </a:solidFill>
+                <a:latin typeface="Noto Sans"/>
+              </a:defRPr>
+            </a:pPr>
+            <a:r>
+              <a:rPr sz="3000" b="1" lang="ja-JP" altLang="en-US">
+                <a:solidFill>
+                  <a:srgbClr val="303437"/>
+                </a:solidFill>
+                <a:latin typeface="Noto Sans"/>
+                <a:ea typeface="Noto Sans CJK JP"/>
+                <a:cs typeface="Noto Sans"/>
+              </a:rPr>
+              <a:t>記号の種類と読み込み方</a:t>
+            </a:r>
+          </a:p>
+          <a:p>
+            <a:pPr marL="457200" indent="-457200">
+              <a:lnSpc>
+                <a:spcPts val="3660"/>
+              </a:lnSpc>
+              <a:spcAft>
+                <a:spcPts val="0"/>
+              </a:spcAft>
+              <a:buSzPct val="100000"/>
+              <a:buFont typeface="Noto Sans CJK JP"/>
+              <a:buAutoNum type="arabicPeriod" startAt="3"/>
+              <a:defRPr sz="3000" b="1">
+                <a:solidFill>
+                  <a:srgbClr val="303437"/>
+                </a:solidFill>
+                <a:latin typeface="Noto Sans"/>
+              </a:defRPr>
+            </a:pPr>
+            <a:r>
+              <a:rPr sz="3000" b="1" lang="ja-JP" altLang="en-US">
+                <a:solidFill>
+                  <a:srgbClr val="303437"/>
+                </a:solidFill>
+                <a:latin typeface="Noto Sans"/>
+                <a:ea typeface="Noto Sans CJK JP"/>
+                <a:cs typeface="Noto Sans"/>
+              </a:rPr>
+              <a:t>研究と参考文献</a:t>
+            </a:r>
+          </a:p>
+        </p:txBody>
+      </p:sp>
+      <p:sp>
+        <p:nvSpPr>
+          <p:cNvPr id="4" name="Title 3"/>
           <p:cNvSpPr>
             <a:spLocks noGrp="1"/>
           </p:cNvSpPr>
@@ -15174,7 +14504,7 @@
                 <a:ea typeface="Noto Sans CJK JP"/>
                 <a:cs typeface="Noto Sans"/>
               </a:rPr>
-              <a:t>Appendix</a:t>
+              <a:t>Appendix: 目次</a:t>
             </a:r>
           </a:p>
         </p:txBody>
@@ -15209,233 +14539,6 @@
         </p:nvSpPr>
         <p:spPr>
           <a:xfrm>
-            <a:off x="468172" y="650138"/>
-            <a:ext cx="8206740" cy="616305"/>
-          </a:xfrm>
-        </p:spPr>
-        <p:txBody>
-          <a:bodyPr wrap="square" lIns="0" rIns="0" tIns="0" bIns="0">
-            <a:noAutofit/>
-          </a:bodyPr>
-          <a:lstStyle/>
-          <a:p>
-            <a:pPr algn="l">
-              <a:lnSpc>
-                <a:spcPct val="110000"/>
-              </a:lnSpc>
-              <a:buNone/>
-              <a:defRPr sz="2800" b="0">
-                <a:solidFill>
-                  <a:srgbClr val="303437"/>
-                </a:solidFill>
-                <a:latin typeface="Noto Sans"/>
-              </a:defRPr>
-            </a:pPr>
-            <a:r>
-              <a:rPr sz="2800" b="1" lang="ja-JP" altLang="en-US">
-                <a:solidFill>
-                  <a:srgbClr val="303437"/>
-                </a:solidFill>
-                <a:latin typeface="Noto Sans"/>
-                <a:ea typeface="Noto Sans CJK JP"/>
-                <a:cs typeface="Noto Sans"/>
-              </a:rPr>
-              <a:t/>
-            </a:r>
-          </a:p>
-        </p:txBody>
-      </p:sp>
-      <p:sp>
-        <p:nvSpPr>
-          <p:cNvPr id="3" name="Text Placeholder 2"/>
-          <p:cNvSpPr>
-            <a:spLocks noGrp="1"/>
-          </p:cNvSpPr>
-          <p:nvPr>
-            <p:ph type="body" idx="1"/>
-          </p:nvPr>
-        </p:nvSpPr>
-        <p:spPr>
-          <a:xfrm>
-            <a:off x="640080" y="1972511"/>
-            <a:ext cx="7863840" cy="1744980"/>
-          </a:xfrm>
-        </p:spPr>
-        <p:txBody>
-          <a:bodyPr lIns="0" rIns="0" tIns="0" bIns="0">
-            <a:noAutofit/>
-          </a:bodyPr>
-          <a:lstStyle/>
-          <a:p>
-            <a:pPr marL="457200" indent="-457200">
-              <a:lnSpc>
-                <a:spcPts val="3660"/>
-              </a:lnSpc>
-              <a:spcAft>
-                <a:spcPts val="1200"/>
-              </a:spcAft>
-              <a:buSzPct val="100000"/>
-              <a:buFont typeface="Noto Sans CJK JP"/>
-              <a:buAutoNum type="arabicPeriod" startAt="1"/>
-              <a:defRPr sz="3000" b="1">
-                <a:solidFill>
-                  <a:srgbClr val="303437"/>
-                </a:solidFill>
-                <a:latin typeface="Noto Sans"/>
-              </a:defRPr>
-            </a:pPr>
-            <a:r>
-              <a:rPr sz="3000" b="1" lang="ja-JP" altLang="en-US">
-                <a:solidFill>
-                  <a:srgbClr val="303437"/>
-                </a:solidFill>
-                <a:latin typeface="Noto Sans"/>
-                <a:ea typeface="Noto Sans CJK JP"/>
-                <a:cs typeface="Noto Sans"/>
-              </a:rPr>
-              <a:t>追加の例題</a:t>
-            </a:r>
-          </a:p>
-          <a:p>
-            <a:pPr marL="457200" indent="-457200">
-              <a:lnSpc>
-                <a:spcPts val="3660"/>
-              </a:lnSpc>
-              <a:spcAft>
-                <a:spcPts val="1200"/>
-              </a:spcAft>
-              <a:buSzPct val="100000"/>
-              <a:buFont typeface="Noto Sans CJK JP"/>
-              <a:buAutoNum type="arabicPeriod" startAt="2"/>
-              <a:defRPr sz="3000" b="1">
-                <a:solidFill>
-                  <a:srgbClr val="303437"/>
-                </a:solidFill>
-                <a:latin typeface="Noto Sans"/>
-              </a:defRPr>
-            </a:pPr>
-            <a:r>
-              <a:rPr sz="3000" b="1" lang="ja-JP" altLang="en-US">
-                <a:solidFill>
-                  <a:srgbClr val="303437"/>
-                </a:solidFill>
-                <a:latin typeface="Noto Sans"/>
-                <a:ea typeface="Noto Sans CJK JP"/>
-                <a:cs typeface="Noto Sans"/>
-              </a:rPr>
-              <a:t>記号の種類と読み込み方</a:t>
-            </a:r>
-          </a:p>
-          <a:p>
-            <a:pPr marL="457200" indent="-457200">
-              <a:lnSpc>
-                <a:spcPts val="3660"/>
-              </a:lnSpc>
-              <a:spcAft>
-                <a:spcPts val="0"/>
-              </a:spcAft>
-              <a:buSzPct val="100000"/>
-              <a:buFont typeface="Noto Sans CJK JP"/>
-              <a:buAutoNum type="arabicPeriod" startAt="3"/>
-              <a:defRPr sz="3000" b="1">
-                <a:solidFill>
-                  <a:srgbClr val="303437"/>
-                </a:solidFill>
-                <a:latin typeface="Noto Sans"/>
-              </a:defRPr>
-            </a:pPr>
-            <a:r>
-              <a:rPr sz="3000" b="1" lang="ja-JP" altLang="en-US">
-                <a:solidFill>
-                  <a:srgbClr val="303437"/>
-                </a:solidFill>
-                <a:latin typeface="Noto Sans"/>
-                <a:ea typeface="Noto Sans CJK JP"/>
-                <a:cs typeface="Noto Sans"/>
-              </a:rPr>
-              <a:t>研究と参考文献</a:t>
-            </a:r>
-          </a:p>
-        </p:txBody>
-      </p:sp>
-      <p:sp>
-        <p:nvSpPr>
-          <p:cNvPr id="4" name="Title 3"/>
-          <p:cNvSpPr>
-            <a:spLocks noGrp="1"/>
-          </p:cNvSpPr>
-          <p:nvPr>
-            <p:ph type="title" idx="2"/>
-          </p:nvPr>
-        </p:nvSpPr>
-        <p:spPr>
-          <a:xfrm>
-            <a:off x="75895" y="0"/>
-            <a:ext cx="8115300" cy="480060"/>
-          </a:xfrm>
-        </p:spPr>
-        <p:txBody>
-          <a:bodyPr wrap="square" lIns="0" rIns="0" tIns="0" bIns="0" anchor="ctr">
-            <a:noAutofit/>
-          </a:bodyPr>
-          <a:lstStyle/>
-          <a:p>
-            <a:pPr algn="l">
-              <a:lnSpc>
-                <a:spcPct val="110000"/>
-              </a:lnSpc>
-              <a:buNone/>
-              <a:defRPr sz="1400" b="0">
-                <a:solidFill>
-                  <a:srgbClr val="303437"/>
-                </a:solidFill>
-                <a:latin typeface="Noto Sans"/>
-              </a:defRPr>
-            </a:pPr>
-            <a:r>
-              <a:rPr sz="1400" b="1" lang="ja-JP" altLang="en-US">
-                <a:solidFill>
-                  <a:srgbClr val="FFFEF8"/>
-                </a:solidFill>
-                <a:latin typeface="Noto Sans"/>
-                <a:ea typeface="Noto Sans CJK JP"/>
-                <a:cs typeface="Noto Sans"/>
-              </a:rPr>
-              <a:t>Appendix: 目次</a:t>
-            </a:r>
-          </a:p>
-        </p:txBody>
-      </p:sp>
-    </p:spTree>
-  </p:cSld>
-  <p:clrMapOvr>
-    <a:masterClrMapping/>
-  </p:clrMapOvr>
-</p:sld>
-</file>
-
-<file path=ppt/slides/slide33.xml><?xml version="1.0" encoding="utf-8"?>
-<p:sld xmlns:a="http://schemas.openxmlformats.org/drawingml/2006/main" xmlns:p="http://schemas.openxmlformats.org/presentationml/2006/main" xmlns:r="http://schemas.openxmlformats.org/officeDocument/2006/relationships">
-  <p:cSld>
-    <p:spTree>
-      <p:nvGrpSpPr>
-        <p:cNvPr id="1" name=""/>
-        <p:cNvGrpSpPr/>
-        <p:nvPr/>
-      </p:nvGrpSpPr>
-      <p:grpSpPr/>
-      <p:sp>
-        <p:nvSpPr>
-          <p:cNvPr id="2" name="Title 1"/>
-          <p:cNvSpPr>
-            <a:spLocks noGrp="1"/>
-          </p:cNvSpPr>
-          <p:nvPr>
-            <p:ph type="title"/>
-          </p:nvPr>
-        </p:nvSpPr>
-        <p:spPr>
-          <a:xfrm>
             <a:off x="548640" y="2506875"/>
             <a:ext cx="8046720" cy="585216"/>
           </a:xfrm>
@@ -15528,7 +14631,7 @@
 </p:sld>
 </file>
 
-<file path=ppt/slides/slide34.xml><?xml version="1.0" encoding="utf-8"?>
+<file path=ppt/slides/slide33.xml><?xml version="1.0" encoding="utf-8"?>
 <p:sld xmlns:a="http://schemas.openxmlformats.org/drawingml/2006/main" xmlns:p="http://schemas.openxmlformats.org/presentationml/2006/main" xmlns:r="http://schemas.openxmlformats.org/officeDocument/2006/relationships">
   <p:cSld>
     <p:spTree>
@@ -16142,7 +15245,7 @@
 </p:sld>
 </file>
 
-<file path=ppt/slides/slide35.xml><?xml version="1.0" encoding="utf-8"?>
+<file path=ppt/slides/slide34.xml><?xml version="1.0" encoding="utf-8"?>
 <p:sld xmlns:a="http://schemas.openxmlformats.org/drawingml/2006/main" xmlns:p="http://schemas.openxmlformats.org/presentationml/2006/main" xmlns:r="http://schemas.openxmlformats.org/officeDocument/2006/relationships">
   <p:cSld>
     <p:spTree>
@@ -16756,7 +15859,7 @@
 </p:sld>
 </file>
 
-<file path=ppt/slides/slide36.xml><?xml version="1.0" encoding="utf-8"?>
+<file path=ppt/slides/slide35.xml><?xml version="1.0" encoding="utf-8"?>
 <p:sld xmlns:a="http://schemas.openxmlformats.org/drawingml/2006/main" xmlns:p="http://schemas.openxmlformats.org/presentationml/2006/main" xmlns:r="http://schemas.openxmlformats.org/officeDocument/2006/relationships">
   <p:cSld>
     <p:spTree>
@@ -17370,7 +16473,7 @@
 </p:sld>
 </file>
 
-<file path=ppt/slides/slide37.xml><?xml version="1.0" encoding="utf-8"?>
+<file path=ppt/slides/slide36.xml><?xml version="1.0" encoding="utf-8"?>
 <p:sld xmlns:a="http://schemas.openxmlformats.org/drawingml/2006/main" xmlns:p="http://schemas.openxmlformats.org/presentationml/2006/main" xmlns:r="http://schemas.openxmlformats.org/officeDocument/2006/relationships">
   <p:cSld>
     <p:spTree>
@@ -17984,7 +17087,7 @@
 </p:sld>
 </file>
 
-<file path=ppt/slides/slide38.xml><?xml version="1.0" encoding="utf-8"?>
+<file path=ppt/slides/slide37.xml><?xml version="1.0" encoding="utf-8"?>
 <p:sld xmlns:a="http://schemas.openxmlformats.org/drawingml/2006/main" xmlns:p="http://schemas.openxmlformats.org/presentationml/2006/main" xmlns:r="http://schemas.openxmlformats.org/officeDocument/2006/relationships">
   <p:cSld>
     <p:spTree>
@@ -18598,7 +17701,7 @@
 </p:sld>
 </file>
 
-<file path=ppt/slides/slide39.xml><?xml version="1.0" encoding="utf-8"?>
+<file path=ppt/slides/slide38.xml><?xml version="1.0" encoding="utf-8"?>
 <p:sld xmlns:a="http://schemas.openxmlformats.org/drawingml/2006/main" xmlns:p="http://schemas.openxmlformats.org/presentationml/2006/main" xmlns:r="http://schemas.openxmlformats.org/officeDocument/2006/relationships">
   <p:cSld>
     <p:spTree>
@@ -19212,121 +18315,7 @@
 </p:sld>
 </file>
 
-<file path=ppt/slides/slide4.xml><?xml version="1.0" encoding="utf-8"?>
-<p:sld xmlns:a="http://schemas.openxmlformats.org/drawingml/2006/main" xmlns:p="http://schemas.openxmlformats.org/presentationml/2006/main" xmlns:r="http://schemas.openxmlformats.org/officeDocument/2006/relationships">
-  <p:cSld>
-    <p:spTree>
-      <p:nvGrpSpPr>
-        <p:cNvPr id="1" name=""/>
-        <p:cNvGrpSpPr/>
-        <p:nvPr/>
-      </p:nvGrpSpPr>
-      <p:grpSpPr/>
-      <p:sp>
-        <p:nvSpPr>
-          <p:cNvPr id="2" name="Title 1"/>
-          <p:cNvSpPr>
-            <a:spLocks noGrp="1"/>
-          </p:cNvSpPr>
-          <p:nvPr>
-            <p:ph type="title"/>
-          </p:nvPr>
-        </p:nvSpPr>
-        <p:spPr>
-          <a:xfrm>
-            <a:off x="548640" y="2506875"/>
-            <a:ext cx="8046720" cy="585216"/>
-          </a:xfrm>
-        </p:spPr>
-        <p:txBody>
-          <a:bodyPr wrap="square" lIns="0" rIns="0" tIns="0" bIns="0" anchor="ctr">
-            <a:noAutofit/>
-          </a:bodyPr>
-          <a:lstStyle/>
-          <a:p>
-            <a:pPr algn="ctr">
-              <a:lnSpc>
-                <a:spcPct val="110000"/>
-              </a:lnSpc>
-              <a:buNone/>
-              <a:defRPr sz="3600" b="0">
-                <a:solidFill>
-                  <a:srgbClr val="303437"/>
-                </a:solidFill>
-                <a:latin typeface="Noto Sans"/>
-              </a:defRPr>
-            </a:pPr>
-            <a:r>
-              <a:rPr sz="3600" b="1" lang="ja-JP" altLang="en-US">
-                <a:solidFill>
-                  <a:srgbClr val="303437"/>
-                </a:solidFill>
-                <a:latin typeface="Noto Sans"/>
-                <a:ea typeface="Noto Sans CJK JP"/>
-                <a:cs typeface="Noto Sans"/>
-              </a:rPr>
-              <a:t>列の最後で、交互の規則を破る</a:t>
-            </a:r>
-          </a:p>
-        </p:txBody>
-      </p:sp>
-      <p:sp>
-        <p:nvSpPr>
-          <p:cNvPr id="3" name="Title 2"/>
-          <p:cNvSpPr>
-            <a:spLocks noGrp="1"/>
-          </p:cNvSpPr>
-          <p:nvPr>
-            <p:ph type="title" idx="2"/>
-          </p:nvPr>
-        </p:nvSpPr>
-        <p:spPr>
-          <a:xfrm>
-            <a:off x="75895" y="0"/>
-            <a:ext cx="8115300" cy="480060"/>
-          </a:xfrm>
-        </p:spPr>
-        <p:txBody>
-          <a:bodyPr wrap="square" lIns="0" rIns="0" tIns="0" bIns="0" anchor="ctr">
-            <a:noAutofit/>
-          </a:bodyPr>
-          <a:lstStyle/>
-          <a:p>
-            <a:pPr algn="l">
-              <a:lnSpc>
-                <a:spcPct val="110000"/>
-              </a:lnSpc>
-              <a:buNone/>
-              <a:defRPr sz="1400" b="0">
-                <a:solidFill>
-                  <a:srgbClr val="303437"/>
-                </a:solidFill>
-                <a:latin typeface="Noto Sans"/>
-              </a:defRPr>
-            </a:pPr>
-            <a:r>
-              <a:rPr sz="1400" b="1" lang="ja-JP" altLang="en-US">
-                <a:solidFill>
-                  <a:srgbClr val="FFFEF8"/>
-                </a:solidFill>
-                <a:latin typeface="Noto Sans"/>
-                <a:ea typeface="Noto Sans CJK JP"/>
-                <a:cs typeface="Noto Sans"/>
-              </a:rPr>
-              <a:t>1. 列の最後で、交互の規則を破る</a:t>
-            </a:r>
-          </a:p>
-        </p:txBody>
-      </p:sp>
-    </p:spTree>
-  </p:cSld>
-  <p:clrMapOvr>
-    <a:masterClrMapping/>
-  </p:clrMapOvr>
-</p:sld>
-</file>
-
-<file path=ppt/slides/slide40.xml><?xml version="1.0" encoding="utf-8"?>
+<file path=ppt/slides/slide39.xml><?xml version="1.0" encoding="utf-8"?>
 <p:sld xmlns:a="http://schemas.openxmlformats.org/drawingml/2006/main" xmlns:p="http://schemas.openxmlformats.org/presentationml/2006/main" xmlns:r="http://schemas.openxmlformats.org/officeDocument/2006/relationships">
   <p:cSld>
     <p:spTree>
@@ -19940,7 +18929,121 @@
 </p:sld>
 </file>
 
-<file path=ppt/slides/slide41.xml><?xml version="1.0" encoding="utf-8"?>
+<file path=ppt/slides/slide4.xml><?xml version="1.0" encoding="utf-8"?>
+<p:sld xmlns:a="http://schemas.openxmlformats.org/drawingml/2006/main" xmlns:p="http://schemas.openxmlformats.org/presentationml/2006/main" xmlns:r="http://schemas.openxmlformats.org/officeDocument/2006/relationships">
+  <p:cSld>
+    <p:spTree>
+      <p:nvGrpSpPr>
+        <p:cNvPr id="1" name=""/>
+        <p:cNvGrpSpPr/>
+        <p:nvPr/>
+      </p:nvGrpSpPr>
+      <p:grpSpPr/>
+      <p:sp>
+        <p:nvSpPr>
+          <p:cNvPr id="2" name="Title 1"/>
+          <p:cNvSpPr>
+            <a:spLocks noGrp="1"/>
+          </p:cNvSpPr>
+          <p:nvPr>
+            <p:ph type="title"/>
+          </p:nvPr>
+        </p:nvSpPr>
+        <p:spPr>
+          <a:xfrm>
+            <a:off x="548640" y="2506875"/>
+            <a:ext cx="8046720" cy="585216"/>
+          </a:xfrm>
+        </p:spPr>
+        <p:txBody>
+          <a:bodyPr wrap="square" lIns="0" rIns="0" tIns="0" bIns="0" anchor="ctr">
+            <a:noAutofit/>
+          </a:bodyPr>
+          <a:lstStyle/>
+          <a:p>
+            <a:pPr algn="ctr">
+              <a:lnSpc>
+                <a:spcPct val="110000"/>
+              </a:lnSpc>
+              <a:buNone/>
+              <a:defRPr sz="3600" b="0">
+                <a:solidFill>
+                  <a:srgbClr val="303437"/>
+                </a:solidFill>
+                <a:latin typeface="Noto Sans"/>
+              </a:defRPr>
+            </a:pPr>
+            <a:r>
+              <a:rPr sz="3600" b="1" lang="ja-JP" altLang="en-US">
+                <a:solidFill>
+                  <a:srgbClr val="303437"/>
+                </a:solidFill>
+                <a:latin typeface="Noto Sans"/>
+                <a:ea typeface="Noto Sans CJK JP"/>
+                <a:cs typeface="Noto Sans"/>
+              </a:rPr>
+              <a:t>列の最後で、交互の規則を破る</a:t>
+            </a:r>
+          </a:p>
+        </p:txBody>
+      </p:sp>
+      <p:sp>
+        <p:nvSpPr>
+          <p:cNvPr id="3" name="Title 2"/>
+          <p:cNvSpPr>
+            <a:spLocks noGrp="1"/>
+          </p:cNvSpPr>
+          <p:nvPr>
+            <p:ph type="title" idx="2"/>
+          </p:nvPr>
+        </p:nvSpPr>
+        <p:spPr>
+          <a:xfrm>
+            <a:off x="75895" y="0"/>
+            <a:ext cx="8115300" cy="480060"/>
+          </a:xfrm>
+        </p:spPr>
+        <p:txBody>
+          <a:bodyPr wrap="square" lIns="0" rIns="0" tIns="0" bIns="0" anchor="ctr">
+            <a:noAutofit/>
+          </a:bodyPr>
+          <a:lstStyle/>
+          <a:p>
+            <a:pPr algn="l">
+              <a:lnSpc>
+                <a:spcPct val="110000"/>
+              </a:lnSpc>
+              <a:buNone/>
+              <a:defRPr sz="1400" b="0">
+                <a:solidFill>
+                  <a:srgbClr val="303437"/>
+                </a:solidFill>
+                <a:latin typeface="Noto Sans"/>
+              </a:defRPr>
+            </a:pPr>
+            <a:r>
+              <a:rPr sz="1400" b="1" lang="ja-JP" altLang="en-US">
+                <a:solidFill>
+                  <a:srgbClr val="FFFEF8"/>
+                </a:solidFill>
+                <a:latin typeface="Noto Sans"/>
+                <a:ea typeface="Noto Sans CJK JP"/>
+                <a:cs typeface="Noto Sans"/>
+              </a:rPr>
+              <a:t>1. 列の最後で、交互の規則を破る</a:t>
+            </a:r>
+          </a:p>
+        </p:txBody>
+      </p:sp>
+    </p:spTree>
+  </p:cSld>
+  <p:clrMapOvr>
+    <a:masterClrMapping/>
+  </p:clrMapOvr>
+</p:sld>
+</file>
+
+<file path=ppt/slides/slide40.xml><?xml version="1.0" encoding="utf-8"?>
 <p:sld xmlns:a="http://schemas.openxmlformats.org/drawingml/2006/main" xmlns:p="http://schemas.openxmlformats.org/presentationml/2006/main" xmlns:r="http://schemas.openxmlformats.org/officeDocument/2006/relationships">
   <p:cSld>
     <p:spTree>
@@ -20554,7 +19657,7 @@
 </p:sld>
 </file>
 
-<file path=ppt/slides/slide42.xml><?xml version="1.0" encoding="utf-8"?>
+<file path=ppt/slides/slide41.xml><?xml version="1.0" encoding="utf-8"?>
 <p:sld xmlns:a="http://schemas.openxmlformats.org/drawingml/2006/main" xmlns:p="http://schemas.openxmlformats.org/presentationml/2006/main" xmlns:r="http://schemas.openxmlformats.org/officeDocument/2006/relationships">
   <p:cSld>
     <p:spTree>
@@ -21168,7 +20271,7 @@
 </p:sld>
 </file>
 
-<file path=ppt/slides/slide43.xml><?xml version="1.0" encoding="utf-8"?>
+<file path=ppt/slides/slide42.xml><?xml version="1.0" encoding="utf-8"?>
 <p:sld xmlns:a="http://schemas.openxmlformats.org/drawingml/2006/main" xmlns:p="http://schemas.openxmlformats.org/presentationml/2006/main" xmlns:r="http://schemas.openxmlformats.org/officeDocument/2006/relationships">
   <p:cSld>
     <p:spTree>
@@ -21782,7 +20885,7 @@
 </p:sld>
 </file>
 
-<file path=ppt/slides/slide44.xml><?xml version="1.0" encoding="utf-8"?>
+<file path=ppt/slides/slide43.xml><?xml version="1.0" encoding="utf-8"?>
 <p:sld xmlns:a="http://schemas.openxmlformats.org/drawingml/2006/main" xmlns:p="http://schemas.openxmlformats.org/presentationml/2006/main" xmlns:r="http://schemas.openxmlformats.org/officeDocument/2006/relationships">
   <p:cSld>
     <p:spTree>
@@ -21896,7 +20999,7 @@
 </p:sld>
 </file>
 
-<file path=ppt/slides/slide45.xml><?xml version="1.0" encoding="utf-8"?>
+<file path=ppt/slides/slide44.xml><?xml version="1.0" encoding="utf-8"?>
 <p:sld xmlns:a="http://schemas.openxmlformats.org/drawingml/2006/main" xmlns:p="http://schemas.openxmlformats.org/presentationml/2006/main" xmlns:r="http://schemas.openxmlformats.org/officeDocument/2006/relationships">
   <p:cSld>
     <p:spTree>
@@ -22838,7 +21941,7 @@
 </p:sld>
 </file>
 
-<file path=ppt/slides/slide46.xml><?xml version="1.0" encoding="utf-8"?>
+<file path=ppt/slides/slide45.xml><?xml version="1.0" encoding="utf-8"?>
 <p:sld xmlns:a="http://schemas.openxmlformats.org/drawingml/2006/main" xmlns:p="http://schemas.openxmlformats.org/presentationml/2006/main" xmlns:r="http://schemas.openxmlformats.org/officeDocument/2006/relationships">
   <p:cSld>
     <p:spTree>
@@ -23780,7 +22883,7 @@
 </p:sld>
 </file>
 
-<file path=ppt/slides/slide49.xml><?xml version="1.0" encoding="utf-8"?>
+<file path=ppt/slides/slide46.xml><?xml version="1.0" encoding="utf-8"?>
 <p:sld xmlns:a="http://schemas.openxmlformats.org/drawingml/2006/main" xmlns:p="http://schemas.openxmlformats.org/presentationml/2006/main" xmlns:r="http://schemas.openxmlformats.org/officeDocument/2006/relationships">
   <p:cSld>
     <p:spTree>
@@ -24274,6 +23377,823 @@
 </p:sld>
 </file>
 
+<file path=ppt/slides/slide47.xml><?xml version="1.0" encoding="utf-8"?>
+<p:sld xmlns:a="http://schemas.openxmlformats.org/drawingml/2006/main" xmlns:p="http://schemas.openxmlformats.org/presentationml/2006/main" xmlns:r="http://schemas.openxmlformats.org/officeDocument/2006/relationships">
+  <p:cSld>
+    <p:spTree>
+      <p:nvGrpSpPr>
+        <p:cNvPr id="1" name=""/>
+        <p:cNvGrpSpPr/>
+        <p:nvPr/>
+      </p:nvGrpSpPr>
+      <p:grpSpPr/>
+      <p:sp>
+        <p:nvSpPr>
+          <p:cNvPr id="2" name="Title 1"/>
+          <p:cNvSpPr>
+            <a:spLocks noGrp="1"/>
+          </p:cNvSpPr>
+          <p:nvPr>
+            <p:ph type="title"/>
+          </p:nvPr>
+        </p:nvSpPr>
+        <p:spPr>
+          <a:xfrm>
+            <a:off x="548640" y="2506875"/>
+            <a:ext cx="8046720" cy="585216"/>
+          </a:xfrm>
+        </p:spPr>
+        <p:txBody>
+          <a:bodyPr wrap="square" lIns="0" rIns="0" tIns="0" bIns="0" anchor="ctr">
+            <a:noAutofit/>
+          </a:bodyPr>
+          <a:lstStyle/>
+          <a:p>
+            <a:pPr algn="ctr">
+              <a:lnSpc>
+                <a:spcPct val="110000"/>
+              </a:lnSpc>
+              <a:buNone/>
+              <a:defRPr sz="3600" b="0">
+                <a:solidFill>
+                  <a:srgbClr val="303437"/>
+                </a:solidFill>
+                <a:latin typeface="Noto Sans"/>
+              </a:defRPr>
+            </a:pPr>
+            <a:r>
+              <a:rPr sz="3600" b="1" lang="ja-JP" altLang="en-US">
+                <a:solidFill>
+                  <a:srgbClr val="303437"/>
+                </a:solidFill>
+                <a:latin typeface="Noto Sans"/>
+                <a:ea typeface="Noto Sans CJK JP"/>
+                <a:cs typeface="Noto Sans"/>
+              </a:rPr>
+              <a:t>研究と参考文献</a:t>
+            </a:r>
+          </a:p>
+        </p:txBody>
+      </p:sp>
+      <p:sp>
+        <p:nvSpPr>
+          <p:cNvPr id="3" name="Title 2"/>
+          <p:cNvSpPr>
+            <a:spLocks noGrp="1"/>
+          </p:cNvSpPr>
+          <p:nvPr>
+            <p:ph type="title" idx="2"/>
+          </p:nvPr>
+        </p:nvSpPr>
+        <p:spPr>
+          <a:xfrm>
+            <a:off x="75895" y="0"/>
+            <a:ext cx="8115300" cy="480060"/>
+          </a:xfrm>
+        </p:spPr>
+        <p:txBody>
+          <a:bodyPr wrap="square" lIns="0" rIns="0" tIns="0" bIns="0" anchor="ctr">
+            <a:noAutofit/>
+          </a:bodyPr>
+          <a:lstStyle/>
+          <a:p>
+            <a:pPr algn="l">
+              <a:lnSpc>
+                <a:spcPct val="110000"/>
+              </a:lnSpc>
+              <a:buNone/>
+              <a:defRPr sz="1400" b="0">
+                <a:solidFill>
+                  <a:srgbClr val="303437"/>
+                </a:solidFill>
+                <a:latin typeface="Noto Sans"/>
+              </a:defRPr>
+            </a:pPr>
+            <a:r>
+              <a:rPr sz="1400" b="1" lang="ja-JP" altLang="en-US">
+                <a:solidFill>
+                  <a:srgbClr val="FFFEF8"/>
+                </a:solidFill>
+                <a:latin typeface="Noto Sans"/>
+                <a:ea typeface="Noto Sans CJK JP"/>
+                <a:cs typeface="Noto Sans"/>
+              </a:rPr>
+              <a:t>Appendix: 3. 研究と参考文献</a:t>
+            </a:r>
+          </a:p>
+        </p:txBody>
+      </p:sp>
+    </p:spTree>
+  </p:cSld>
+  <p:clrMapOvr>
+    <a:masterClrMapping/>
+  </p:clrMapOvr>
+</p:sld>
+</file>
+
+<file path=ppt/slides/slide48.xml><?xml version="1.0" encoding="utf-8"?>
+<p:sld xmlns:a="http://schemas.openxmlformats.org/drawingml/2006/main" xmlns:p="http://schemas.openxmlformats.org/presentationml/2006/main" xmlns:r="http://schemas.openxmlformats.org/officeDocument/2006/relationships">
+  <p:cSld>
+    <p:spTree>
+      <p:nvGrpSpPr>
+        <p:cNvPr id="1" name=""/>
+        <p:cNvGrpSpPr/>
+        <p:nvPr/>
+      </p:nvGrpSpPr>
+      <p:grpSpPr/>
+      <p:sp>
+        <p:nvSpPr>
+          <p:cNvPr id="2" name="Title 1"/>
+          <p:cNvSpPr>
+            <a:spLocks noGrp="1"/>
+          </p:cNvSpPr>
+          <p:nvPr>
+            <p:ph type="title"/>
+          </p:nvPr>
+        </p:nvSpPr>
+        <p:spPr>
+          <a:xfrm>
+            <a:off x="468172" y="650138"/>
+            <a:ext cx="8206740" cy="616305"/>
+          </a:xfrm>
+        </p:spPr>
+        <p:txBody>
+          <a:bodyPr wrap="square" lIns="0" rIns="0" tIns="0" bIns="0">
+            <a:noAutofit/>
+          </a:bodyPr>
+          <a:lstStyle/>
+          <a:p>
+            <a:pPr algn="l">
+              <a:lnSpc>
+                <a:spcPct val="110000"/>
+              </a:lnSpc>
+              <a:buNone/>
+              <a:defRPr sz="2800" b="0">
+                <a:solidFill>
+                  <a:srgbClr val="303437"/>
+                </a:solidFill>
+                <a:latin typeface="Noto Sans"/>
+              </a:defRPr>
+            </a:pPr>
+            <a:r>
+              <a:rPr sz="2450" b="1" lang="ja-JP" altLang="en-US">
+                <a:solidFill>
+                  <a:srgbClr val="303437"/>
+                </a:solidFill>
+                <a:latin typeface="Noto Sans"/>
+                <a:ea typeface="Noto Sans CJK JP"/>
+                <a:cs typeface="Noto Sans"/>
+              </a:rPr>
+              <a:t>Tomasz Korbakの課題が、指示と規則の衝突を示す</a:t>
+            </a:r>
+          </a:p>
+        </p:txBody>
+      </p:sp>
+      <p:sp>
+        <p:nvSpPr>
+          <p:cNvPr id="3" name="Text Placeholder 2"/>
+          <p:cNvSpPr>
+            <a:spLocks noGrp="1"/>
+          </p:cNvSpPr>
+          <p:nvPr>
+            <p:ph type="body" idx="1"/>
+          </p:nvPr>
+        </p:nvSpPr>
+        <p:spPr>
+          <a:xfrm>
+            <a:off x="594360" y="1463040"/>
+            <a:ext cx="7955279" cy="3044952"/>
+          </a:xfrm>
+        </p:spPr>
+        <p:txBody>
+          <a:bodyPr wrap="square" tIns="91440" bIns="91440">
+            <a:noAutofit/>
+          </a:bodyPr>
+          <a:lstStyle/>
+          <a:p>
+            <a:pPr marL="457200" indent="-355600">
+              <a:lnSpc>
+                <a:spcPts val="2499"/>
+              </a:lnSpc>
+              <a:spcAft>
+                <a:spcPts val="700"/>
+              </a:spcAft>
+              <a:buSzPct val="63333"/>
+              <a:buFont typeface="Noto Sans CJK JP"/>
+              <a:buChar char="●"/>
+              <a:defRPr sz="2100" b="0">
+                <a:solidFill>
+                  <a:srgbClr val="303437"/>
+                </a:solidFill>
+                <a:latin typeface="Noto Sans"/>
+              </a:defRPr>
+            </a:pPr>
+            <a:r>
+              <a:rPr sz="2100" b="0" lang="ja-JP" altLang="en-US">
+                <a:solidFill>
+                  <a:srgbClr val="303437"/>
+                </a:solidFill>
+                <a:latin typeface="Noto Sans"/>
+                <a:ea typeface="Noto Sans CJK JP"/>
+                <a:cs typeface="Noto Sans"/>
+              </a:rPr>
+              <a:t>提出者はTomasz Korbak。Inverse Scaling Prizeの第2回受賞課題として、明示的な指示より暗黙の繰返しを優先する現象を扱う。</a:t>
+            </a:r>
+          </a:p>
+          <a:p>
+            <a:pPr marL="457200" indent="-355600">
+              <a:lnSpc>
+                <a:spcPts val="2499"/>
+              </a:lnSpc>
+              <a:spcAft>
+                <a:spcPts val="700"/>
+              </a:spcAft>
+              <a:buSzPct val="63333"/>
+              <a:buFont typeface="Noto Sans CJK JP"/>
+              <a:buChar char="●"/>
+              <a:defRPr sz="2100" b="0">
+                <a:solidFill>
+                  <a:srgbClr val="303437"/>
+                </a:solidFill>
+                <a:latin typeface="Noto Sans"/>
+              </a:defRPr>
+            </a:pPr>
+            <a:r>
+              <a:rPr sz="2100" b="0" lang="ja-JP" altLang="en-US">
+                <a:solidFill>
+                  <a:srgbClr val="303437"/>
+                </a:solidFill>
+                <a:latin typeface="Noto Sans"/>
+                <a:ea typeface="Noto Sans CJK JP"/>
+                <a:cs typeface="Noto Sans"/>
+              </a:rPr>
+              <a:t>McKenzieらの2023年TMLR論文は、11受賞課題を4つの原因仮説で整理する。本課題はDistractor Taskの一例。</a:t>
+            </a:r>
+          </a:p>
+          <a:p>
+            <a:pPr marL="457200" indent="-355600">
+              <a:lnSpc>
+                <a:spcPts val="2499"/>
+              </a:lnSpc>
+              <a:spcAft>
+                <a:spcPts val="0"/>
+              </a:spcAft>
+              <a:buSzPct val="63333"/>
+              <a:buFont typeface="Noto Sans CJK JP"/>
+              <a:buChar char="●"/>
+              <a:defRPr sz="2100" b="0">
+                <a:solidFill>
+                  <a:srgbClr val="303437"/>
+                </a:solidFill>
+                <a:latin typeface="Noto Sans"/>
+              </a:defRPr>
+            </a:pPr>
+            <a:r>
+              <a:rPr sz="2100" b="0" lang="ja-JP" altLang="en-US">
+                <a:solidFill>
+                  <a:srgbClr val="303437"/>
+                </a:solidFill>
+                <a:latin typeface="Noto Sans"/>
+                <a:ea typeface="Noto Sans CJK JP"/>
+                <a:cs typeface="Noto Sans"/>
+              </a:rPr>
+              <a:t>研究では人が選ぶ回答はデータの正解とよく一致する一方、モデルの規模や例示数によって違う傾向が現れることを報告する。</a:t>
+            </a:r>
+          </a:p>
+        </p:txBody>
+      </p:sp>
+      <p:sp>
+        <p:nvSpPr>
+          <p:cNvPr id="4" name="Title 3"/>
+          <p:cNvSpPr>
+            <a:spLocks noGrp="1"/>
+          </p:cNvSpPr>
+          <p:nvPr>
+            <p:ph type="title" idx="2"/>
+          </p:nvPr>
+        </p:nvSpPr>
+        <p:spPr>
+          <a:xfrm>
+            <a:off x="75895" y="0"/>
+            <a:ext cx="8115300" cy="480060"/>
+          </a:xfrm>
+        </p:spPr>
+        <p:txBody>
+          <a:bodyPr wrap="square" lIns="0" rIns="0" tIns="0" bIns="0" anchor="ctr">
+            <a:noAutofit/>
+          </a:bodyPr>
+          <a:lstStyle/>
+          <a:p>
+            <a:pPr algn="l">
+              <a:lnSpc>
+                <a:spcPct val="110000"/>
+              </a:lnSpc>
+              <a:buNone/>
+              <a:defRPr sz="1400" b="0">
+                <a:solidFill>
+                  <a:srgbClr val="303437"/>
+                </a:solidFill>
+                <a:latin typeface="Noto Sans"/>
+              </a:defRPr>
+            </a:pPr>
+            <a:r>
+              <a:rPr sz="1400" b="1" lang="ja-JP" altLang="en-US">
+                <a:solidFill>
+                  <a:srgbClr val="FFFEF8"/>
+                </a:solidFill>
+                <a:latin typeface="Noto Sans"/>
+                <a:ea typeface="Noto Sans CJK JP"/>
+                <a:cs typeface="Noto Sans"/>
+              </a:rPr>
+              <a:t>Appendix: 3. 研究と参考文献</a:t>
+            </a:r>
+          </a:p>
+        </p:txBody>
+      </p:sp>
+      <p:sp>
+        <p:nvSpPr>
+          <p:cNvPr id="5" name="sources"/>
+          <p:cNvSpPr txBox="1"/>
+          <p:nvPr/>
+        </p:nvSpPr>
+        <p:spPr>
+          <a:xfrm>
+            <a:off x="502920" y="4699000"/>
+            <a:ext cx="8183879" cy="431800"/>
+          </a:xfrm>
+          <a:prstGeom prst="rect">
+            <a:avLst/>
+          </a:prstGeom>
+          <a:noFill/>
+        </p:spPr>
+        <p:txBody>
+          <a:bodyPr wrap="square" lIns="0" rIns="0" tIns="0" bIns="0">
+            <a:noAutofit/>
+          </a:bodyPr>
+          <a:lstStyle/>
+          <a:p>
+            <a:pPr algn="l">
+              <a:lnSpc>
+                <a:spcPts val="1200"/>
+              </a:lnSpc>
+              <a:spcBef>
+                <a:spcPts val="0"/>
+              </a:spcBef>
+              <a:spcAft>
+                <a:spcPts val="0"/>
+              </a:spcAft>
+              <a:buNone/>
+              <a:defRPr sz="810" b="0">
+                <a:solidFill>
+                  <a:srgbClr val="303437"/>
+                </a:solidFill>
+                <a:latin typeface="Noto Sans"/>
+              </a:defRPr>
+            </a:pPr>
+            <a:r>
+              <a:rPr sz="830">
+                <a:latin typeface="Noto Sans CJK JP"/>
+              </a:rPr>
+              <a:t>[1] McKenzie et al. (2023). Inverse Scaling: When Bigger Isn’t Better. TMLR.</a:t>
+            </a:r>
+          </a:p>
+          <a:p>
+            <a:pPr>
+              <a:spcBef>
+                <a:spcPts val="0"/>
+              </a:spcBef>
+              <a:spcAft>
+                <a:spcPts val="0"/>
+              </a:spcAft>
+            </a:pPr>
+            <a:r>
+              <a:rPr sz="830">
+                <a:latin typeface="Noto Sans CJK JP"/>
+                <a:hlinkClick r:id="rId2"/>
+              </a:rPr>
+              <a:t>https://arxiv.org/abs/2306.09479</a:t>
+            </a:r>
+          </a:p>
+        </p:txBody>
+      </p:sp>
+    </p:spTree>
+  </p:cSld>
+  <p:clrMapOvr>
+    <a:masterClrMapping/>
+  </p:clrMapOvr>
+</p:sld>
+</file>
+
+<file path=ppt/slides/slide49.xml><?xml version="1.0" encoding="utf-8"?>
+<p:sld xmlns:a="http://schemas.openxmlformats.org/drawingml/2006/main" xmlns:p="http://schemas.openxmlformats.org/presentationml/2006/main" xmlns:r="http://schemas.openxmlformats.org/officeDocument/2006/relationships">
+  <p:cSld>
+    <p:spTree>
+      <p:nvGrpSpPr>
+        <p:cNvPr id="1" name=""/>
+        <p:cNvGrpSpPr/>
+        <p:nvPr/>
+      </p:nvGrpSpPr>
+      <p:grpSpPr/>
+      <p:sp>
+        <p:nvSpPr>
+          <p:cNvPr id="2" name="Title 1"/>
+          <p:cNvSpPr>
+            <a:spLocks noGrp="1"/>
+          </p:cNvSpPr>
+          <p:nvPr>
+            <p:ph type="title"/>
+          </p:nvPr>
+        </p:nvSpPr>
+        <p:spPr>
+          <a:xfrm>
+            <a:off x="468172" y="650138"/>
+            <a:ext cx="8206740" cy="616305"/>
+          </a:xfrm>
+        </p:spPr>
+        <p:txBody>
+          <a:bodyPr wrap="square" lIns="0" rIns="0" tIns="0" bIns="0">
+            <a:noAutofit/>
+          </a:bodyPr>
+          <a:lstStyle/>
+          <a:p>
+            <a:pPr algn="l">
+              <a:lnSpc>
+                <a:spcPct val="110000"/>
+              </a:lnSpc>
+              <a:buNone/>
+              <a:defRPr sz="2800" b="0">
+                <a:solidFill>
+                  <a:srgbClr val="303437"/>
+                </a:solidFill>
+                <a:latin typeface="Noto Sans"/>
+              </a:defRPr>
+            </a:pPr>
+            <a:r>
+              <a:rPr sz="2800" b="1" lang="ja-JP" altLang="en-US">
+                <a:solidFill>
+                  <a:srgbClr val="303437"/>
+                </a:solidFill>
+                <a:latin typeface="Noto Sans"/>
+                <a:ea typeface="Noto Sans CJK JP"/>
+                <a:cs typeface="Noto Sans"/>
+              </a:rPr>
+              <a:t>参考文献</a:t>
+            </a:r>
+          </a:p>
+        </p:txBody>
+      </p:sp>
+      <p:sp>
+        <p:nvSpPr>
+          <p:cNvPr id="3" name="Title 2"/>
+          <p:cNvSpPr>
+            <a:spLocks noGrp="1"/>
+          </p:cNvSpPr>
+          <p:nvPr>
+            <p:ph type="title" idx="2"/>
+          </p:nvPr>
+        </p:nvSpPr>
+        <p:spPr>
+          <a:xfrm>
+            <a:off x="75895" y="0"/>
+            <a:ext cx="8115300" cy="480060"/>
+          </a:xfrm>
+        </p:spPr>
+        <p:txBody>
+          <a:bodyPr wrap="square" lIns="0" rIns="0" tIns="0" bIns="0" anchor="ctr">
+            <a:noAutofit/>
+          </a:bodyPr>
+          <a:lstStyle/>
+          <a:p>
+            <a:pPr algn="l">
+              <a:lnSpc>
+                <a:spcPct val="110000"/>
+              </a:lnSpc>
+              <a:buNone/>
+              <a:defRPr sz="1400" b="0">
+                <a:solidFill>
+                  <a:srgbClr val="303437"/>
+                </a:solidFill>
+                <a:latin typeface="Noto Sans"/>
+              </a:defRPr>
+            </a:pPr>
+            <a:r>
+              <a:rPr sz="1400" b="1" lang="ja-JP" altLang="en-US">
+                <a:solidFill>
+                  <a:srgbClr val="FFFEF8"/>
+                </a:solidFill>
+                <a:latin typeface="Noto Sans"/>
+                <a:ea typeface="Noto Sans CJK JP"/>
+                <a:cs typeface="Noto Sans"/>
+              </a:rPr>
+              <a:t>Appendix: 3. 研究と参考文献</a:t>
+            </a:r>
+          </a:p>
+        </p:txBody>
+      </p:sp>
+      <p:sp>
+        <p:nvSpPr>
+          <p:cNvPr id="4" name="文献 1: Inverse Scaling: When Bigger Isn’t Better"/>
+          <p:cNvSpPr txBox="1"/>
+          <p:nvPr/>
+        </p:nvSpPr>
+        <p:spPr>
+          <a:xfrm>
+            <a:off x="548640" y="1417320"/>
+            <a:ext cx="8046720" cy="1536574"/>
+          </a:xfrm>
+          <a:prstGeom prst="rect">
+            <a:avLst/>
+          </a:prstGeom>
+          <a:noFill/>
+        </p:spPr>
+        <p:txBody>
+          <a:bodyPr wrap="square" lIns="0" rIns="0" tIns="0" bIns="0">
+            <a:noAutofit/>
+          </a:bodyPr>
+          <a:lstStyle/>
+          <a:p>
+            <a:pPr algn="l">
+              <a:lnSpc>
+                <a:spcPct val="114000"/>
+              </a:lnSpc>
+              <a:spcBef>
+                <a:spcPts val="0"/>
+              </a:spcBef>
+              <a:spcAft>
+                <a:spcPts val="400"/>
+              </a:spcAft>
+              <a:buNone/>
+              <a:defRPr sz="1800" b="0">
+                <a:solidFill>
+                  <a:srgbClr val="303437"/>
+                </a:solidFill>
+                <a:latin typeface="Noto Sans"/>
+              </a:defRPr>
+            </a:pPr>
+            <a:r>
+              <a:rPr sz="1800" b="1" lang="ja-JP" altLang="en-US">
+                <a:solidFill>
+                  <a:srgbClr val="303437"/>
+                </a:solidFill>
+                <a:latin typeface="Noto Sans"/>
+                <a:ea typeface="Noto Sans CJK JP"/>
+                <a:cs typeface="Noto Sans"/>
+              </a:rPr>
+              <a:t>Inverse Scaling: When Bigger Isn’t Better</a:t>
+            </a:r>
+          </a:p>
+          <a:p>
+            <a:pPr algn="l">
+              <a:lnSpc>
+                <a:spcPct val="114000"/>
+              </a:lnSpc>
+              <a:spcBef>
+                <a:spcPts val="0"/>
+              </a:spcBef>
+              <a:spcAft>
+                <a:spcPts val="500"/>
+              </a:spcAft>
+              <a:buNone/>
+              <a:defRPr sz="1250" b="0">
+                <a:solidFill>
+                  <a:srgbClr val="303437"/>
+                </a:solidFill>
+                <a:latin typeface="Noto Sans"/>
+              </a:defRPr>
+            </a:pPr>
+            <a:r>
+              <a:rPr sz="1250" b="0" lang="ja-JP" altLang="en-US">
+                <a:solidFill>
+                  <a:srgbClr val="626669"/>
+                </a:solidFill>
+                <a:latin typeface="Noto Sans"/>
+                <a:ea typeface="Noto Sans CJK JP"/>
+                <a:cs typeface="Noto Sans"/>
+              </a:rPr>
+              <a:t>Ian R. McKenzie et al. (2023). Transactions on Machine Learning Research. arXiv v2:2024.</a:t>
+            </a:r>
+          </a:p>
+          <a:p>
+            <a:pPr algn="l">
+              <a:lnSpc>
+                <a:spcPct val="114000"/>
+              </a:lnSpc>
+              <a:spcBef>
+                <a:spcPts val="0"/>
+              </a:spcBef>
+              <a:spcAft>
+                <a:spcPts val="400"/>
+              </a:spcAft>
+              <a:buNone/>
+              <a:defRPr sz="1750" b="0">
+                <a:solidFill>
+                  <a:srgbClr val="303437"/>
+                </a:solidFill>
+                <a:latin typeface="Noto Sans"/>
+              </a:defRPr>
+            </a:pPr>
+            <a:r>
+              <a:rPr sz="1750" b="0" lang="ja-JP" altLang="en-US">
+                <a:solidFill>
+                  <a:srgbClr val="303437"/>
+                </a:solidFill>
+                <a:latin typeface="Noto Sans"/>
+                <a:ea typeface="Noto Sans CJK JP"/>
+                <a:cs typeface="Noto Sans"/>
+              </a:rPr>
+              <a:t>11受賞課題を評価し、交互列の完遂が指示への切替を妨げるという仮説と、規模・例示数の影響を報告する。</a:t>
+            </a:r>
+          </a:p>
+          <a:p>
+            <a:pPr algn="l">
+              <a:lnSpc>
+                <a:spcPct val="114000"/>
+              </a:lnSpc>
+              <a:spcBef>
+                <a:spcPts val="0"/>
+              </a:spcBef>
+              <a:spcAft>
+                <a:spcPts val="0"/>
+              </a:spcAft>
+              <a:buNone/>
+              <a:defRPr sz="1050" b="0">
+                <a:solidFill>
+                  <a:srgbClr val="303437"/>
+                </a:solidFill>
+                <a:latin typeface="Noto Sans"/>
+              </a:defRPr>
+            </a:pPr>
+            <a:r>
+              <a:rPr sz="1050" b="0" lang="ja-JP" altLang="en-US">
+                <a:solidFill>
+                  <a:srgbClr val="626669"/>
+                </a:solidFill>
+                <a:latin typeface="Noto Sans"/>
+                <a:ea typeface="Noto Sans CJK JP"/>
+                <a:cs typeface="Noto Sans"/>
+                <a:hlinkClick r:id="rId2"/>
+              </a:rPr>
+              <a:t>https://arxiv.org/abs/2306.09479</a:t>
+            </a:r>
+          </a:p>
+        </p:txBody>
+      </p:sp>
+      <p:sp>
+        <p:nvSpPr>
+          <p:cNvPr id="5" name="文献 2: Inverse Scaling Prize — Data release"/>
+          <p:cNvSpPr txBox="1"/>
+          <p:nvPr/>
+        </p:nvSpPr>
+        <p:spPr>
+          <a:xfrm>
+            <a:off x="548640" y="2987548"/>
+            <a:ext cx="8046720" cy="1536663"/>
+          </a:xfrm>
+          <a:prstGeom prst="rect">
+            <a:avLst/>
+          </a:prstGeom>
+          <a:noFill/>
+        </p:spPr>
+        <p:txBody>
+          <a:bodyPr wrap="square" lIns="0" rIns="0" tIns="0" bIns="0">
+            <a:noAutofit/>
+          </a:bodyPr>
+          <a:lstStyle/>
+          <a:p>
+            <a:pPr algn="l">
+              <a:lnSpc>
+                <a:spcPct val="114000"/>
+              </a:lnSpc>
+              <a:spcBef>
+                <a:spcPts val="0"/>
+              </a:spcBef>
+              <a:spcAft>
+                <a:spcPts val="400"/>
+              </a:spcAft>
+              <a:buNone/>
+              <a:defRPr sz="1800" b="0">
+                <a:solidFill>
+                  <a:srgbClr val="303437"/>
+                </a:solidFill>
+                <a:latin typeface="Noto Sans"/>
+              </a:defRPr>
+            </a:pPr>
+            <a:r>
+              <a:rPr sz="1800" b="1" lang="ja-JP" altLang="en-US">
+                <a:solidFill>
+                  <a:srgbClr val="303437"/>
+                </a:solidFill>
+                <a:latin typeface="Noto Sans"/>
+                <a:ea typeface="Noto Sans CJK JP"/>
+                <a:cs typeface="Noto Sans"/>
+              </a:rPr>
+              <a:t>Inverse Scaling Prize — Data release</a:t>
+            </a:r>
+          </a:p>
+          <a:p>
+            <a:pPr algn="l">
+              <a:lnSpc>
+                <a:spcPct val="114000"/>
+              </a:lnSpc>
+              <a:spcBef>
+                <a:spcPts val="0"/>
+              </a:spcBef>
+              <a:spcAft>
+                <a:spcPts val="500"/>
+              </a:spcAft>
+              <a:buNone/>
+              <a:defRPr sz="1250" b="0">
+                <a:solidFill>
+                  <a:srgbClr val="303437"/>
+                </a:solidFill>
+                <a:latin typeface="Noto Sans"/>
+              </a:defRPr>
+            </a:pPr>
+            <a:r>
+              <a:rPr sz="1250" b="0" lang="ja-JP" altLang="en-US">
+                <a:solidFill>
+                  <a:srgbClr val="626669"/>
+                </a:solidFill>
+                <a:latin typeface="Noto Sans"/>
+                <a:ea typeface="Noto Sans CJK JP"/>
+                <a:cs typeface="Noto Sans"/>
+              </a:rPr>
+              <a:t>Inverse Scaling Prize. 2023年3月公開。課題提出者Tomasz Korbak。</a:t>
+            </a:r>
+          </a:p>
+          <a:p>
+            <a:pPr algn="l">
+              <a:lnSpc>
+                <a:spcPct val="114000"/>
+              </a:lnSpc>
+              <a:spcBef>
+                <a:spcPts val="0"/>
+              </a:spcBef>
+              <a:spcAft>
+                <a:spcPts val="400"/>
+              </a:spcAft>
+              <a:buNone/>
+              <a:defRPr sz="1750" b="0">
+                <a:solidFill>
+                  <a:srgbClr val="303437"/>
+                </a:solidFill>
+                <a:latin typeface="Noto Sans"/>
+              </a:defRPr>
+            </a:pPr>
+            <a:r>
+              <a:rPr sz="1750" b="0" lang="ja-JP" altLang="en-US">
+                <a:solidFill>
+                  <a:srgbClr val="303437"/>
+                </a:solidFill>
+                <a:latin typeface="Noto Sans"/>
+                <a:ea typeface="Noto Sans CJK JP"/>
+                <a:cs typeface="Noto Sans"/>
+              </a:rPr>
+              <a:t>11課題のJSONLと候補確率による評価形式を公開し、CC BY4.0の条件と変更履歴を示す。</a:t>
+            </a:r>
+          </a:p>
+          <a:p>
+            <a:pPr algn="l">
+              <a:lnSpc>
+                <a:spcPct val="114000"/>
+              </a:lnSpc>
+              <a:spcBef>
+                <a:spcPts val="0"/>
+              </a:spcBef>
+              <a:spcAft>
+                <a:spcPts val="0"/>
+              </a:spcAft>
+              <a:buNone/>
+              <a:defRPr sz="1050" b="0">
+                <a:solidFill>
+                  <a:srgbClr val="303437"/>
+                </a:solidFill>
+                <a:latin typeface="Noto Sans"/>
+              </a:defRPr>
+            </a:pPr>
+            <a:r>
+              <a:rPr sz="1050" b="0" lang="ja-JP" altLang="en-US">
+                <a:solidFill>
+                  <a:srgbClr val="626669"/>
+                </a:solidFill>
+                <a:latin typeface="Noto Sans"/>
+                <a:ea typeface="Noto Sans CJK JP"/>
+                <a:cs typeface="Noto Sans"/>
+                <a:hlinkClick r:id="rId3"/>
+              </a:rPr>
+              <a:t>https://github.com/inverse-scaling/prize/blob/main/data-release/README.md</a:t>
+            </a:r>
+          </a:p>
+        </p:txBody>
+      </p:sp>
+    </p:spTree>
+  </p:cSld>
+  <p:clrMapOvr>
+    <a:masterClrMapping/>
+  </p:clrMapOvr>
+</p:sld>
+</file>
+
 <file path=ppt/slides/slide5.xml><?xml version="1.0" encoding="utf-8"?>
 <p:sld xmlns:a="http://schemas.openxmlformats.org/drawingml/2006/main" xmlns:p="http://schemas.openxmlformats.org/presentationml/2006/main" xmlns:r="http://schemas.openxmlformats.org/officeDocument/2006/relationships">
   <p:cSld>
@@ -24589,38 +24509,38 @@
         </p:nvSpPr>
         <p:spPr>
           <a:xfrm>
-            <a:off x="548640" y="2506875"/>
-            <a:ext cx="8046720" cy="585216"/>
+            <a:off x="468172" y="650138"/>
+            <a:ext cx="8206740" cy="616305"/>
           </a:xfrm>
         </p:spPr>
         <p:txBody>
-          <a:bodyPr wrap="square" lIns="0" rIns="0" tIns="0" bIns="0" anchor="ctr">
+          <a:bodyPr wrap="square" lIns="0" rIns="0" tIns="0" bIns="0">
             <a:noAutofit/>
           </a:bodyPr>
           <a:lstStyle/>
           <a:p>
-            <a:pPr algn="ctr">
+            <a:pPr algn="l">
               <a:lnSpc>
                 <a:spcPct val="110000"/>
               </a:lnSpc>
               <a:buNone/>
-              <a:defRPr sz="3600" b="0">
-                <a:solidFill>
-                  <a:srgbClr val="303437"/>
-                </a:solidFill>
-                <a:latin typeface="Noto Sans"/>
-              </a:defRPr>
-            </a:pPr>
-            <a:r>
-              <a:rPr sz="3600" b="1" lang="ja-JP" altLang="en-US">
-                <a:solidFill>
-                  <a:srgbClr val="303437"/>
-                </a:solidFill>
-                <a:latin typeface="Noto Sans"/>
-                <a:ea typeface="Noto Sans CJK JP"/>
-                <a:cs typeface="Noto Sans"/>
-              </a:rPr>
-              <a:t>研究と参考文献</a:t>
+              <a:defRPr sz="2800" b="0">
+                <a:solidFill>
+                  <a:srgbClr val="303437"/>
+                </a:solidFill>
+                <a:latin typeface="Noto Sans"/>
+              </a:defRPr>
+            </a:pPr>
+            <a:r>
+              <a:rPr sz="2800" b="1" lang="ja-JP" altLang="en-US">
+                <a:solidFill>
+                  <a:srgbClr val="303437"/>
+                </a:solidFill>
+                <a:latin typeface="Noto Sans"/>
+                <a:ea typeface="Noto Sans CJK JP"/>
+                <a:cs typeface="Noto Sans"/>
+              </a:rPr>
+              <a:t>参考文献</a:t>
             </a:r>
           </a:p>
         </p:txBody>
@@ -24673,823 +24593,6 @@
           </a:p>
         </p:txBody>
       </p:sp>
-    </p:spTree>
-  </p:cSld>
-  <p:clrMapOvr>
-    <a:masterClrMapping/>
-  </p:clrMapOvr>
-</p:sld>
-</file>
-
-<file path=ppt/slides/slide51.xml><?xml version="1.0" encoding="utf-8"?>
-<p:sld xmlns:a="http://schemas.openxmlformats.org/drawingml/2006/main" xmlns:p="http://schemas.openxmlformats.org/presentationml/2006/main" xmlns:r="http://schemas.openxmlformats.org/officeDocument/2006/relationships">
-  <p:cSld>
-    <p:spTree>
-      <p:nvGrpSpPr>
-        <p:cNvPr id="1" name=""/>
-        <p:cNvGrpSpPr/>
-        <p:nvPr/>
-      </p:nvGrpSpPr>
-      <p:grpSpPr/>
-      <p:sp>
-        <p:nvSpPr>
-          <p:cNvPr id="2" name="Title 1"/>
-          <p:cNvSpPr>
-            <a:spLocks noGrp="1"/>
-          </p:cNvSpPr>
-          <p:nvPr>
-            <p:ph type="title"/>
-          </p:nvPr>
-        </p:nvSpPr>
-        <p:spPr>
-          <a:xfrm>
-            <a:off x="468172" y="650138"/>
-            <a:ext cx="8206740" cy="616305"/>
-          </a:xfrm>
-        </p:spPr>
-        <p:txBody>
-          <a:bodyPr wrap="square" lIns="0" rIns="0" tIns="0" bIns="0">
-            <a:noAutofit/>
-          </a:bodyPr>
-          <a:lstStyle/>
-          <a:p>
-            <a:pPr algn="l">
-              <a:lnSpc>
-                <a:spcPct val="110000"/>
-              </a:lnSpc>
-              <a:buNone/>
-              <a:defRPr sz="2800" b="0">
-                <a:solidFill>
-                  <a:srgbClr val="303437"/>
-                </a:solidFill>
-                <a:latin typeface="Noto Sans"/>
-              </a:defRPr>
-            </a:pPr>
-            <a:r>
-              <a:rPr sz="2450" b="1" lang="ja-JP" altLang="en-US">
-                <a:solidFill>
-                  <a:srgbClr val="303437"/>
-                </a:solidFill>
-                <a:latin typeface="Noto Sans"/>
-                <a:ea typeface="Noto Sans CJK JP"/>
-                <a:cs typeface="Noto Sans"/>
-              </a:rPr>
-              <a:t>Tomasz Korbakの課題が、指示と規則の衝突を示す</a:t>
-            </a:r>
-          </a:p>
-        </p:txBody>
-      </p:sp>
-      <p:sp>
-        <p:nvSpPr>
-          <p:cNvPr id="3" name="Text Placeholder 2"/>
-          <p:cNvSpPr>
-            <a:spLocks noGrp="1"/>
-          </p:cNvSpPr>
-          <p:nvPr>
-            <p:ph type="body" idx="1"/>
-          </p:nvPr>
-        </p:nvSpPr>
-        <p:spPr>
-          <a:xfrm>
-            <a:off x="594360" y="1463040"/>
-            <a:ext cx="7955279" cy="3044952"/>
-          </a:xfrm>
-        </p:spPr>
-        <p:txBody>
-          <a:bodyPr wrap="square" tIns="91440" bIns="91440">
-            <a:noAutofit/>
-          </a:bodyPr>
-          <a:lstStyle/>
-          <a:p>
-            <a:pPr marL="457200" indent="-355600">
-              <a:lnSpc>
-                <a:spcPts val="2499"/>
-              </a:lnSpc>
-              <a:spcAft>
-                <a:spcPts val="700"/>
-              </a:spcAft>
-              <a:buSzPct val="63333"/>
-              <a:buFont typeface="Noto Sans CJK JP"/>
-              <a:buChar char="●"/>
-              <a:defRPr sz="2100" b="0">
-                <a:solidFill>
-                  <a:srgbClr val="303437"/>
-                </a:solidFill>
-                <a:latin typeface="Noto Sans"/>
-              </a:defRPr>
-            </a:pPr>
-            <a:r>
-              <a:rPr sz="2100" b="0" lang="ja-JP" altLang="en-US">
-                <a:solidFill>
-                  <a:srgbClr val="303437"/>
-                </a:solidFill>
-                <a:latin typeface="Noto Sans"/>
-                <a:ea typeface="Noto Sans CJK JP"/>
-                <a:cs typeface="Noto Sans"/>
-              </a:rPr>
-              <a:t>提出者はTomasz Korbak。Inverse Scaling Prizeの第2回受賞課題として、明示的な指示より暗黙の繰返しを優先する現象を扱う。</a:t>
-            </a:r>
-          </a:p>
-          <a:p>
-            <a:pPr marL="457200" indent="-355600">
-              <a:lnSpc>
-                <a:spcPts val="2499"/>
-              </a:lnSpc>
-              <a:spcAft>
-                <a:spcPts val="700"/>
-              </a:spcAft>
-              <a:buSzPct val="63333"/>
-              <a:buFont typeface="Noto Sans CJK JP"/>
-              <a:buChar char="●"/>
-              <a:defRPr sz="2100" b="0">
-                <a:solidFill>
-                  <a:srgbClr val="303437"/>
-                </a:solidFill>
-                <a:latin typeface="Noto Sans"/>
-              </a:defRPr>
-            </a:pPr>
-            <a:r>
-              <a:rPr sz="2100" b="0" lang="ja-JP" altLang="en-US">
-                <a:solidFill>
-                  <a:srgbClr val="303437"/>
-                </a:solidFill>
-                <a:latin typeface="Noto Sans"/>
-                <a:ea typeface="Noto Sans CJK JP"/>
-                <a:cs typeface="Noto Sans"/>
-              </a:rPr>
-              <a:t>McKenzieらの2023年TMLR論文は、11受賞課題を4つの原因仮説で整理する。本課題はDistractor Taskの一例。</a:t>
-            </a:r>
-          </a:p>
-          <a:p>
-            <a:pPr marL="457200" indent="-355600">
-              <a:lnSpc>
-                <a:spcPts val="2499"/>
-              </a:lnSpc>
-              <a:spcAft>
-                <a:spcPts val="0"/>
-              </a:spcAft>
-              <a:buSzPct val="63333"/>
-              <a:buFont typeface="Noto Sans CJK JP"/>
-              <a:buChar char="●"/>
-              <a:defRPr sz="2100" b="0">
-                <a:solidFill>
-                  <a:srgbClr val="303437"/>
-                </a:solidFill>
-                <a:latin typeface="Noto Sans"/>
-              </a:defRPr>
-            </a:pPr>
-            <a:r>
-              <a:rPr sz="2100" b="0" lang="ja-JP" altLang="en-US">
-                <a:solidFill>
-                  <a:srgbClr val="303437"/>
-                </a:solidFill>
-                <a:latin typeface="Noto Sans"/>
-                <a:ea typeface="Noto Sans CJK JP"/>
-                <a:cs typeface="Noto Sans"/>
-              </a:rPr>
-              <a:t>研究では人が選ぶ回答はデータの正解とよく一致する一方、モデルの規模や例示数によって違う傾向が現れることを報告する。</a:t>
-            </a:r>
-          </a:p>
-        </p:txBody>
-      </p:sp>
-      <p:sp>
-        <p:nvSpPr>
-          <p:cNvPr id="4" name="Title 3"/>
-          <p:cNvSpPr>
-            <a:spLocks noGrp="1"/>
-          </p:cNvSpPr>
-          <p:nvPr>
-            <p:ph type="title" idx="2"/>
-          </p:nvPr>
-        </p:nvSpPr>
-        <p:spPr>
-          <a:xfrm>
-            <a:off x="75895" y="0"/>
-            <a:ext cx="8115300" cy="480060"/>
-          </a:xfrm>
-        </p:spPr>
-        <p:txBody>
-          <a:bodyPr wrap="square" lIns="0" rIns="0" tIns="0" bIns="0" anchor="ctr">
-            <a:noAutofit/>
-          </a:bodyPr>
-          <a:lstStyle/>
-          <a:p>
-            <a:pPr algn="l">
-              <a:lnSpc>
-                <a:spcPct val="110000"/>
-              </a:lnSpc>
-              <a:buNone/>
-              <a:defRPr sz="1400" b="0">
-                <a:solidFill>
-                  <a:srgbClr val="303437"/>
-                </a:solidFill>
-                <a:latin typeface="Noto Sans"/>
-              </a:defRPr>
-            </a:pPr>
-            <a:r>
-              <a:rPr sz="1400" b="1" lang="ja-JP" altLang="en-US">
-                <a:solidFill>
-                  <a:srgbClr val="FFFEF8"/>
-                </a:solidFill>
-                <a:latin typeface="Noto Sans"/>
-                <a:ea typeface="Noto Sans CJK JP"/>
-                <a:cs typeface="Noto Sans"/>
-              </a:rPr>
-              <a:t>Appendix: 3. 研究と参考文献</a:t>
-            </a:r>
-          </a:p>
-        </p:txBody>
-      </p:sp>
-      <p:sp>
-        <p:nvSpPr>
-          <p:cNvPr id="5" name="sources"/>
-          <p:cNvSpPr txBox="1"/>
-          <p:nvPr/>
-        </p:nvSpPr>
-        <p:spPr>
-          <a:xfrm>
-            <a:off x="502920" y="4699000"/>
-            <a:ext cx="8183879" cy="431800"/>
-          </a:xfrm>
-          <a:prstGeom prst="rect">
-            <a:avLst/>
-          </a:prstGeom>
-          <a:noFill/>
-        </p:spPr>
-        <p:txBody>
-          <a:bodyPr wrap="square" lIns="0" rIns="0" tIns="0" bIns="0">
-            <a:noAutofit/>
-          </a:bodyPr>
-          <a:lstStyle/>
-          <a:p>
-            <a:pPr algn="l">
-              <a:lnSpc>
-                <a:spcPts val="1200"/>
-              </a:lnSpc>
-              <a:spcBef>
-                <a:spcPts val="0"/>
-              </a:spcBef>
-              <a:spcAft>
-                <a:spcPts val="0"/>
-              </a:spcAft>
-              <a:buNone/>
-              <a:defRPr sz="810" b="0">
-                <a:solidFill>
-                  <a:srgbClr val="303437"/>
-                </a:solidFill>
-                <a:latin typeface="Noto Sans"/>
-              </a:defRPr>
-            </a:pPr>
-            <a:r>
-              <a:rPr sz="830">
-                <a:latin typeface="Noto Sans CJK JP"/>
-              </a:rPr>
-              <a:t>[1] McKenzie et al. (2023). Inverse Scaling: When Bigger Isn’t Better. TMLR.</a:t>
-            </a:r>
-          </a:p>
-          <a:p>
-            <a:pPr>
-              <a:spcBef>
-                <a:spcPts val="0"/>
-              </a:spcBef>
-              <a:spcAft>
-                <a:spcPts val="0"/>
-              </a:spcAft>
-            </a:pPr>
-            <a:r>
-              <a:rPr sz="830">
-                <a:latin typeface="Noto Sans CJK JP"/>
-                <a:hlinkClick r:id="rId2"/>
-              </a:rPr>
-              <a:t>https://arxiv.org/abs/2306.09479</a:t>
-            </a:r>
-          </a:p>
-        </p:txBody>
-      </p:sp>
-    </p:spTree>
-  </p:cSld>
-  <p:clrMapOvr>
-    <a:masterClrMapping/>
-  </p:clrMapOvr>
-</p:sld>
-</file>
-
-<file path=ppt/slides/slide52.xml><?xml version="1.0" encoding="utf-8"?>
-<p:sld xmlns:a="http://schemas.openxmlformats.org/drawingml/2006/main" xmlns:p="http://schemas.openxmlformats.org/presentationml/2006/main" xmlns:r="http://schemas.openxmlformats.org/officeDocument/2006/relationships">
-  <p:cSld>
-    <p:spTree>
-      <p:nvGrpSpPr>
-        <p:cNvPr id="1" name=""/>
-        <p:cNvGrpSpPr/>
-        <p:nvPr/>
-      </p:nvGrpSpPr>
-      <p:grpSpPr/>
-      <p:sp>
-        <p:nvSpPr>
-          <p:cNvPr id="2" name="Title 1"/>
-          <p:cNvSpPr>
-            <a:spLocks noGrp="1"/>
-          </p:cNvSpPr>
-          <p:nvPr>
-            <p:ph type="title"/>
-          </p:nvPr>
-        </p:nvSpPr>
-        <p:spPr>
-          <a:xfrm>
-            <a:off x="468172" y="650138"/>
-            <a:ext cx="8206740" cy="616305"/>
-          </a:xfrm>
-        </p:spPr>
-        <p:txBody>
-          <a:bodyPr wrap="square" lIns="0" rIns="0" tIns="0" bIns="0">
-            <a:noAutofit/>
-          </a:bodyPr>
-          <a:lstStyle/>
-          <a:p>
-            <a:pPr algn="l">
-              <a:lnSpc>
-                <a:spcPct val="110000"/>
-              </a:lnSpc>
-              <a:buNone/>
-              <a:defRPr sz="2800" b="0">
-                <a:solidFill>
-                  <a:srgbClr val="303437"/>
-                </a:solidFill>
-                <a:latin typeface="Noto Sans"/>
-              </a:defRPr>
-            </a:pPr>
-            <a:r>
-              <a:rPr sz="2800" b="1" lang="ja-JP" altLang="en-US">
-                <a:solidFill>
-                  <a:srgbClr val="303437"/>
-                </a:solidFill>
-                <a:latin typeface="Noto Sans"/>
-                <a:ea typeface="Noto Sans CJK JP"/>
-                <a:cs typeface="Noto Sans"/>
-              </a:rPr>
-              <a:t>参考文献</a:t>
-            </a:r>
-          </a:p>
-        </p:txBody>
-      </p:sp>
-      <p:sp>
-        <p:nvSpPr>
-          <p:cNvPr id="3" name="Title 2"/>
-          <p:cNvSpPr>
-            <a:spLocks noGrp="1"/>
-          </p:cNvSpPr>
-          <p:nvPr>
-            <p:ph type="title" idx="2"/>
-          </p:nvPr>
-        </p:nvSpPr>
-        <p:spPr>
-          <a:xfrm>
-            <a:off x="75895" y="0"/>
-            <a:ext cx="8115300" cy="480060"/>
-          </a:xfrm>
-        </p:spPr>
-        <p:txBody>
-          <a:bodyPr wrap="square" lIns="0" rIns="0" tIns="0" bIns="0" anchor="ctr">
-            <a:noAutofit/>
-          </a:bodyPr>
-          <a:lstStyle/>
-          <a:p>
-            <a:pPr algn="l">
-              <a:lnSpc>
-                <a:spcPct val="110000"/>
-              </a:lnSpc>
-              <a:buNone/>
-              <a:defRPr sz="1400" b="0">
-                <a:solidFill>
-                  <a:srgbClr val="303437"/>
-                </a:solidFill>
-                <a:latin typeface="Noto Sans"/>
-              </a:defRPr>
-            </a:pPr>
-            <a:r>
-              <a:rPr sz="1400" b="1" lang="ja-JP" altLang="en-US">
-                <a:solidFill>
-                  <a:srgbClr val="FFFEF8"/>
-                </a:solidFill>
-                <a:latin typeface="Noto Sans"/>
-                <a:ea typeface="Noto Sans CJK JP"/>
-                <a:cs typeface="Noto Sans"/>
-              </a:rPr>
-              <a:t>Appendix: 3. 研究と参考文献</a:t>
-            </a:r>
-          </a:p>
-        </p:txBody>
-      </p:sp>
-      <p:sp>
-        <p:nvSpPr>
-          <p:cNvPr id="4" name="文献 1: Inverse Scaling: When Bigger Isn’t Better"/>
-          <p:cNvSpPr txBox="1"/>
-          <p:nvPr/>
-        </p:nvSpPr>
-        <p:spPr>
-          <a:xfrm>
-            <a:off x="548640" y="1417320"/>
-            <a:ext cx="8046720" cy="1536574"/>
-          </a:xfrm>
-          <a:prstGeom prst="rect">
-            <a:avLst/>
-          </a:prstGeom>
-          <a:noFill/>
-        </p:spPr>
-        <p:txBody>
-          <a:bodyPr wrap="square" lIns="0" rIns="0" tIns="0" bIns="0">
-            <a:noAutofit/>
-          </a:bodyPr>
-          <a:lstStyle/>
-          <a:p>
-            <a:pPr algn="l">
-              <a:lnSpc>
-                <a:spcPct val="114000"/>
-              </a:lnSpc>
-              <a:spcBef>
-                <a:spcPts val="0"/>
-              </a:spcBef>
-              <a:spcAft>
-                <a:spcPts val="400"/>
-              </a:spcAft>
-              <a:buNone/>
-              <a:defRPr sz="1800" b="0">
-                <a:solidFill>
-                  <a:srgbClr val="303437"/>
-                </a:solidFill>
-                <a:latin typeface="Noto Sans"/>
-              </a:defRPr>
-            </a:pPr>
-            <a:r>
-              <a:rPr sz="1800" b="1" lang="ja-JP" altLang="en-US">
-                <a:solidFill>
-                  <a:srgbClr val="303437"/>
-                </a:solidFill>
-                <a:latin typeface="Noto Sans"/>
-                <a:ea typeface="Noto Sans CJK JP"/>
-                <a:cs typeface="Noto Sans"/>
-              </a:rPr>
-              <a:t>Inverse Scaling: When Bigger Isn’t Better</a:t>
-            </a:r>
-          </a:p>
-          <a:p>
-            <a:pPr algn="l">
-              <a:lnSpc>
-                <a:spcPct val="114000"/>
-              </a:lnSpc>
-              <a:spcBef>
-                <a:spcPts val="0"/>
-              </a:spcBef>
-              <a:spcAft>
-                <a:spcPts val="500"/>
-              </a:spcAft>
-              <a:buNone/>
-              <a:defRPr sz="1250" b="0">
-                <a:solidFill>
-                  <a:srgbClr val="303437"/>
-                </a:solidFill>
-                <a:latin typeface="Noto Sans"/>
-              </a:defRPr>
-            </a:pPr>
-            <a:r>
-              <a:rPr sz="1250" b="0" lang="ja-JP" altLang="en-US">
-                <a:solidFill>
-                  <a:srgbClr val="626669"/>
-                </a:solidFill>
-                <a:latin typeface="Noto Sans"/>
-                <a:ea typeface="Noto Sans CJK JP"/>
-                <a:cs typeface="Noto Sans"/>
-              </a:rPr>
-              <a:t>Ian R. McKenzie et al. (2023). Transactions on Machine Learning Research. arXiv v2:2024.</a:t>
-            </a:r>
-          </a:p>
-          <a:p>
-            <a:pPr algn="l">
-              <a:lnSpc>
-                <a:spcPct val="114000"/>
-              </a:lnSpc>
-              <a:spcBef>
-                <a:spcPts val="0"/>
-              </a:spcBef>
-              <a:spcAft>
-                <a:spcPts val="400"/>
-              </a:spcAft>
-              <a:buNone/>
-              <a:defRPr sz="1750" b="0">
-                <a:solidFill>
-                  <a:srgbClr val="303437"/>
-                </a:solidFill>
-                <a:latin typeface="Noto Sans"/>
-              </a:defRPr>
-            </a:pPr>
-            <a:r>
-              <a:rPr sz="1750" b="0" lang="ja-JP" altLang="en-US">
-                <a:solidFill>
-                  <a:srgbClr val="303437"/>
-                </a:solidFill>
-                <a:latin typeface="Noto Sans"/>
-                <a:ea typeface="Noto Sans CJK JP"/>
-                <a:cs typeface="Noto Sans"/>
-              </a:rPr>
-              <a:t>11受賞課題を評価し、交互列の完遂が指示への切替を妨げるという仮説と、規模・例示数の影響を報告する。</a:t>
-            </a:r>
-          </a:p>
-          <a:p>
-            <a:pPr algn="l">
-              <a:lnSpc>
-                <a:spcPct val="114000"/>
-              </a:lnSpc>
-              <a:spcBef>
-                <a:spcPts val="0"/>
-              </a:spcBef>
-              <a:spcAft>
-                <a:spcPts val="0"/>
-              </a:spcAft>
-              <a:buNone/>
-              <a:defRPr sz="1050" b="0">
-                <a:solidFill>
-                  <a:srgbClr val="303437"/>
-                </a:solidFill>
-                <a:latin typeface="Noto Sans"/>
-              </a:defRPr>
-            </a:pPr>
-            <a:r>
-              <a:rPr sz="1050" b="0" lang="ja-JP" altLang="en-US">
-                <a:solidFill>
-                  <a:srgbClr val="626669"/>
-                </a:solidFill>
-                <a:latin typeface="Noto Sans"/>
-                <a:ea typeface="Noto Sans CJK JP"/>
-                <a:cs typeface="Noto Sans"/>
-                <a:hlinkClick r:id="rId2"/>
-              </a:rPr>
-              <a:t>https://arxiv.org/abs/2306.09479</a:t>
-            </a:r>
-          </a:p>
-        </p:txBody>
-      </p:sp>
-      <p:sp>
-        <p:nvSpPr>
-          <p:cNvPr id="5" name="文献 2: Inverse Scaling Prize — Data release"/>
-          <p:cNvSpPr txBox="1"/>
-          <p:nvPr/>
-        </p:nvSpPr>
-        <p:spPr>
-          <a:xfrm>
-            <a:off x="548640" y="2987548"/>
-            <a:ext cx="8046720" cy="1536663"/>
-          </a:xfrm>
-          <a:prstGeom prst="rect">
-            <a:avLst/>
-          </a:prstGeom>
-          <a:noFill/>
-        </p:spPr>
-        <p:txBody>
-          <a:bodyPr wrap="square" lIns="0" rIns="0" tIns="0" bIns="0">
-            <a:noAutofit/>
-          </a:bodyPr>
-          <a:lstStyle/>
-          <a:p>
-            <a:pPr algn="l">
-              <a:lnSpc>
-                <a:spcPct val="114000"/>
-              </a:lnSpc>
-              <a:spcBef>
-                <a:spcPts val="0"/>
-              </a:spcBef>
-              <a:spcAft>
-                <a:spcPts val="400"/>
-              </a:spcAft>
-              <a:buNone/>
-              <a:defRPr sz="1800" b="0">
-                <a:solidFill>
-                  <a:srgbClr val="303437"/>
-                </a:solidFill>
-                <a:latin typeface="Noto Sans"/>
-              </a:defRPr>
-            </a:pPr>
-            <a:r>
-              <a:rPr sz="1800" b="1" lang="ja-JP" altLang="en-US">
-                <a:solidFill>
-                  <a:srgbClr val="303437"/>
-                </a:solidFill>
-                <a:latin typeface="Noto Sans"/>
-                <a:ea typeface="Noto Sans CJK JP"/>
-                <a:cs typeface="Noto Sans"/>
-              </a:rPr>
-              <a:t>Inverse Scaling Prize — Data release</a:t>
-            </a:r>
-          </a:p>
-          <a:p>
-            <a:pPr algn="l">
-              <a:lnSpc>
-                <a:spcPct val="114000"/>
-              </a:lnSpc>
-              <a:spcBef>
-                <a:spcPts val="0"/>
-              </a:spcBef>
-              <a:spcAft>
-                <a:spcPts val="500"/>
-              </a:spcAft>
-              <a:buNone/>
-              <a:defRPr sz="1250" b="0">
-                <a:solidFill>
-                  <a:srgbClr val="303437"/>
-                </a:solidFill>
-                <a:latin typeface="Noto Sans"/>
-              </a:defRPr>
-            </a:pPr>
-            <a:r>
-              <a:rPr sz="1250" b="0" lang="ja-JP" altLang="en-US">
-                <a:solidFill>
-                  <a:srgbClr val="626669"/>
-                </a:solidFill>
-                <a:latin typeface="Noto Sans"/>
-                <a:ea typeface="Noto Sans CJK JP"/>
-                <a:cs typeface="Noto Sans"/>
-              </a:rPr>
-              <a:t>Inverse Scaling Prize. 2023年3月公開。課題提出者Tomasz Korbak。</a:t>
-            </a:r>
-          </a:p>
-          <a:p>
-            <a:pPr algn="l">
-              <a:lnSpc>
-                <a:spcPct val="114000"/>
-              </a:lnSpc>
-              <a:spcBef>
-                <a:spcPts val="0"/>
-              </a:spcBef>
-              <a:spcAft>
-                <a:spcPts val="400"/>
-              </a:spcAft>
-              <a:buNone/>
-              <a:defRPr sz="1750" b="0">
-                <a:solidFill>
-                  <a:srgbClr val="303437"/>
-                </a:solidFill>
-                <a:latin typeface="Noto Sans"/>
-              </a:defRPr>
-            </a:pPr>
-            <a:r>
-              <a:rPr sz="1750" b="0" lang="ja-JP" altLang="en-US">
-                <a:solidFill>
-                  <a:srgbClr val="303437"/>
-                </a:solidFill>
-                <a:latin typeface="Noto Sans"/>
-                <a:ea typeface="Noto Sans CJK JP"/>
-                <a:cs typeface="Noto Sans"/>
-              </a:rPr>
-              <a:t>11課題のJSONLと候補確率による評価形式を公開し、CC BY4.0の条件と変更履歴を示す。</a:t>
-            </a:r>
-          </a:p>
-          <a:p>
-            <a:pPr algn="l">
-              <a:lnSpc>
-                <a:spcPct val="114000"/>
-              </a:lnSpc>
-              <a:spcBef>
-                <a:spcPts val="0"/>
-              </a:spcBef>
-              <a:spcAft>
-                <a:spcPts val="0"/>
-              </a:spcAft>
-              <a:buNone/>
-              <a:defRPr sz="1050" b="0">
-                <a:solidFill>
-                  <a:srgbClr val="303437"/>
-                </a:solidFill>
-                <a:latin typeface="Noto Sans"/>
-              </a:defRPr>
-            </a:pPr>
-            <a:r>
-              <a:rPr sz="1050" b="0" lang="ja-JP" altLang="en-US">
-                <a:solidFill>
-                  <a:srgbClr val="626669"/>
-                </a:solidFill>
-                <a:latin typeface="Noto Sans"/>
-                <a:ea typeface="Noto Sans CJK JP"/>
-                <a:cs typeface="Noto Sans"/>
-                <a:hlinkClick r:id="rId3"/>
-              </a:rPr>
-              <a:t>https://github.com/inverse-scaling/prize/blob/main/data-release/README.md</a:t>
-            </a:r>
-          </a:p>
-        </p:txBody>
-      </p:sp>
-    </p:spTree>
-  </p:cSld>
-  <p:clrMapOvr>
-    <a:masterClrMapping/>
-  </p:clrMapOvr>
-</p:sld>
-</file>
-
-<file path=ppt/slides/slide53.xml><?xml version="1.0" encoding="utf-8"?>
-<p:sld xmlns:a="http://schemas.openxmlformats.org/drawingml/2006/main" xmlns:p="http://schemas.openxmlformats.org/presentationml/2006/main" xmlns:r="http://schemas.openxmlformats.org/officeDocument/2006/relationships">
-  <p:cSld>
-    <p:spTree>
-      <p:nvGrpSpPr>
-        <p:cNvPr id="1" name=""/>
-        <p:cNvGrpSpPr/>
-        <p:nvPr/>
-      </p:nvGrpSpPr>
-      <p:grpSpPr/>
-      <p:sp>
-        <p:nvSpPr>
-          <p:cNvPr id="2" name="Title 1"/>
-          <p:cNvSpPr>
-            <a:spLocks noGrp="1"/>
-          </p:cNvSpPr>
-          <p:nvPr>
-            <p:ph type="title"/>
-          </p:nvPr>
-        </p:nvSpPr>
-        <p:spPr>
-          <a:xfrm>
-            <a:off x="468172" y="650138"/>
-            <a:ext cx="8206740" cy="616305"/>
-          </a:xfrm>
-        </p:spPr>
-        <p:txBody>
-          <a:bodyPr wrap="square" lIns="0" rIns="0" tIns="0" bIns="0">
-            <a:noAutofit/>
-          </a:bodyPr>
-          <a:lstStyle/>
-          <a:p>
-            <a:pPr algn="l">
-              <a:lnSpc>
-                <a:spcPct val="110000"/>
-              </a:lnSpc>
-              <a:buNone/>
-              <a:defRPr sz="2800" b="0">
-                <a:solidFill>
-                  <a:srgbClr val="303437"/>
-                </a:solidFill>
-                <a:latin typeface="Noto Sans"/>
-              </a:defRPr>
-            </a:pPr>
-            <a:r>
-              <a:rPr sz="2800" b="1" lang="ja-JP" altLang="en-US">
-                <a:solidFill>
-                  <a:srgbClr val="303437"/>
-                </a:solidFill>
-                <a:latin typeface="Noto Sans"/>
-                <a:ea typeface="Noto Sans CJK JP"/>
-                <a:cs typeface="Noto Sans"/>
-              </a:rPr>
-              <a:t>参考文献</a:t>
-            </a:r>
-          </a:p>
-        </p:txBody>
-      </p:sp>
-      <p:sp>
-        <p:nvSpPr>
-          <p:cNvPr id="3" name="Title 2"/>
-          <p:cNvSpPr>
-            <a:spLocks noGrp="1"/>
-          </p:cNvSpPr>
-          <p:nvPr>
-            <p:ph type="title" idx="2"/>
-          </p:nvPr>
-        </p:nvSpPr>
-        <p:spPr>
-          <a:xfrm>
-            <a:off x="75895" y="0"/>
-            <a:ext cx="8115300" cy="480060"/>
-          </a:xfrm>
-        </p:spPr>
-        <p:txBody>
-          <a:bodyPr wrap="square" lIns="0" rIns="0" tIns="0" bIns="0" anchor="ctr">
-            <a:noAutofit/>
-          </a:bodyPr>
-          <a:lstStyle/>
-          <a:p>
-            <a:pPr algn="l">
-              <a:lnSpc>
-                <a:spcPct val="110000"/>
-              </a:lnSpc>
-              <a:buNone/>
-              <a:defRPr sz="1400" b="0">
-                <a:solidFill>
-                  <a:srgbClr val="303437"/>
-                </a:solidFill>
-                <a:latin typeface="Noto Sans"/>
-              </a:defRPr>
-            </a:pPr>
-            <a:r>
-              <a:rPr sz="1400" b="1" lang="ja-JP" altLang="en-US">
-                <a:solidFill>
-                  <a:srgbClr val="FFFEF8"/>
-                </a:solidFill>
-                <a:latin typeface="Noto Sans"/>
-                <a:ea typeface="Noto Sans CJK JP"/>
-                <a:cs typeface="Noto Sans"/>
-              </a:rPr>
-              <a:t>Appendix: 3. 研究と参考文献</a:t>
-            </a:r>
-          </a:p>
-        </p:txBody>
-      </p:sp>
       <p:sp>
         <p:nvSpPr>
           <p:cNvPr id="4" name="文献 1: Inverse Scaling Prize: Second Round Winners"/>
@@ -25640,14 +24743,14 @@
       </p:sp>
       <p:sp>
         <p:nvSpPr>
-          <p:cNvPr id="5" name="文献 2: CLEVA: Chinese Language Models EVAluation Platform"/>
+          <p:cNvPr id="5" name="文献 2: Attribution 4.0 International"/>
           <p:cNvSpPr txBox="1"/>
           <p:nvPr/>
         </p:nvSpPr>
         <p:spPr>
           <a:xfrm>
             <a:off x="548640" y="2987548"/>
-            <a:ext cx="8046720" cy="1233184"/>
+            <a:ext cx="8046720" cy="1549400"/>
           </a:xfrm>
           <a:prstGeom prst="rect">
             <a:avLst/>
@@ -25687,7 +24790,7 @@
                 <a:ea typeface="Noto Sans CJK JP"/>
                 <a:cs typeface="Noto Sans"/>
               </a:rPr>
-              <a:t>CLEVA: Chinese Language Models EVAluation Platform</a:t>
+              <a:t>Attribution 4.0 International (CC BY 4.0)</a:t>
             </a:r>
           </a:p>
           <a:p>
@@ -25718,7 +24821,7 @@
                 <a:ea typeface="Noto Sans CJK JP"/>
                 <a:cs typeface="Noto Sans"/>
               </a:rPr>
-              <a:t>Yanyang Li et al. (2023). EMNLP System Demonstrations, pp.186–217.</a:t>
+              <a:t>Creative Commons (n.d.). 参照2026-10-18。</a:t>
             </a:r>
           </a:p>
           <a:p>
@@ -25749,417 +24852,7 @@
                 <a:ea typeface="Noto Sans CJK JP"/>
                 <a:cs typeface="Noto Sans"/>
               </a:rPr>
-              <a:t>中国語モデル評価の基盤を提案し、本課題を指示追従の素材として採用する。</a:t>
-            </a:r>
-          </a:p>
-          <a:p>
-            <a:pPr algn="l">
-              <a:lnSpc>
-                <a:spcPct val="114000"/>
-              </a:lnSpc>
-              <a:spcBef>
-                <a:spcPts val="0"/>
-              </a:spcBef>
-              <a:spcAft>
-                <a:spcPts val="0"/>
-              </a:spcAft>
-              <a:buNone/>
-              <a:defRPr sz="1050" b="0">
-                <a:solidFill>
-                  <a:srgbClr val="303437"/>
-                </a:solidFill>
-                <a:latin typeface="Noto Sans"/>
-              </a:defRPr>
-            </a:pPr>
-            <a:r>
-              <a:rPr sz="1050" b="0" lang="ja-JP" altLang="en-US">
-                <a:solidFill>
-                  <a:srgbClr val="626669"/>
-                </a:solidFill>
-                <a:latin typeface="Noto Sans"/>
-                <a:ea typeface="Noto Sans CJK JP"/>
-                <a:cs typeface="Noto Sans"/>
-                <a:hlinkClick r:id="rId3"/>
-              </a:rPr>
-              <a:t>https://aclanthology.org/2023.emnlp-demo.17/</a:t>
-            </a:r>
-          </a:p>
-        </p:txBody>
-      </p:sp>
-    </p:spTree>
-  </p:cSld>
-  <p:clrMapOvr>
-    <a:masterClrMapping/>
-  </p:clrMapOvr>
-</p:sld>
-</file>
-
-<file path=ppt/slides/slide54.xml><?xml version="1.0" encoding="utf-8"?>
-<p:sld xmlns:a="http://schemas.openxmlformats.org/drawingml/2006/main" xmlns:p="http://schemas.openxmlformats.org/presentationml/2006/main" xmlns:r="http://schemas.openxmlformats.org/officeDocument/2006/relationships">
-  <p:cSld>
-    <p:spTree>
-      <p:nvGrpSpPr>
-        <p:cNvPr id="1" name=""/>
-        <p:cNvGrpSpPr/>
-        <p:nvPr/>
-      </p:nvGrpSpPr>
-      <p:grpSpPr/>
-      <p:sp>
-        <p:nvSpPr>
-          <p:cNvPr id="2" name="Title 1"/>
-          <p:cNvSpPr>
-            <a:spLocks noGrp="1"/>
-          </p:cNvSpPr>
-          <p:nvPr>
-            <p:ph type="title"/>
-          </p:nvPr>
-        </p:nvSpPr>
-        <p:spPr>
-          <a:xfrm>
-            <a:off x="468172" y="650138"/>
-            <a:ext cx="8206740" cy="616305"/>
-          </a:xfrm>
-        </p:spPr>
-        <p:txBody>
-          <a:bodyPr wrap="square" lIns="0" rIns="0" tIns="0" bIns="0">
-            <a:noAutofit/>
-          </a:bodyPr>
-          <a:lstStyle/>
-          <a:p>
-            <a:pPr algn="l">
-              <a:lnSpc>
-                <a:spcPct val="110000"/>
-              </a:lnSpc>
-              <a:buNone/>
-              <a:defRPr sz="2800" b="0">
-                <a:solidFill>
-                  <a:srgbClr val="303437"/>
-                </a:solidFill>
-                <a:latin typeface="Noto Sans"/>
-              </a:defRPr>
-            </a:pPr>
-            <a:r>
-              <a:rPr sz="2800" b="1" lang="ja-JP" altLang="en-US">
-                <a:solidFill>
-                  <a:srgbClr val="303437"/>
-                </a:solidFill>
-                <a:latin typeface="Noto Sans"/>
-                <a:ea typeface="Noto Sans CJK JP"/>
-                <a:cs typeface="Noto Sans"/>
-              </a:rPr>
-              <a:t>参考文献</a:t>
-            </a:r>
-          </a:p>
-        </p:txBody>
-      </p:sp>
-      <p:sp>
-        <p:nvSpPr>
-          <p:cNvPr id="3" name="Title 2"/>
-          <p:cNvSpPr>
-            <a:spLocks noGrp="1"/>
-          </p:cNvSpPr>
-          <p:nvPr>
-            <p:ph type="title" idx="2"/>
-          </p:nvPr>
-        </p:nvSpPr>
-        <p:spPr>
-          <a:xfrm>
-            <a:off x="75895" y="0"/>
-            <a:ext cx="8115300" cy="480060"/>
-          </a:xfrm>
-        </p:spPr>
-        <p:txBody>
-          <a:bodyPr wrap="square" lIns="0" rIns="0" tIns="0" bIns="0" anchor="ctr">
-            <a:noAutofit/>
-          </a:bodyPr>
-          <a:lstStyle/>
-          <a:p>
-            <a:pPr algn="l">
-              <a:lnSpc>
-                <a:spcPct val="110000"/>
-              </a:lnSpc>
-              <a:buNone/>
-              <a:defRPr sz="1400" b="0">
-                <a:solidFill>
-                  <a:srgbClr val="303437"/>
-                </a:solidFill>
-                <a:latin typeface="Noto Sans"/>
-              </a:defRPr>
-            </a:pPr>
-            <a:r>
-              <a:rPr sz="1400" b="1" lang="ja-JP" altLang="en-US">
-                <a:solidFill>
-                  <a:srgbClr val="FFFEF8"/>
-                </a:solidFill>
-                <a:latin typeface="Noto Sans"/>
-                <a:ea typeface="Noto Sans CJK JP"/>
-                <a:cs typeface="Noto Sans"/>
-              </a:rPr>
-              <a:t>Appendix: 3. 研究と参考文献</a:t>
-            </a:r>
-          </a:p>
-        </p:txBody>
-      </p:sp>
-      <p:sp>
-        <p:nvSpPr>
-          <p:cNvPr id="4" name="文献 1: CLEVAInstructionFollowingScenario"/>
-          <p:cNvSpPr txBox="1"/>
-          <p:nvPr/>
-        </p:nvSpPr>
-        <p:spPr>
-          <a:xfrm>
-            <a:off x="548640" y="1417320"/>
-            <a:ext cx="8046720" cy="1536574"/>
-          </a:xfrm>
-          <a:prstGeom prst="rect">
-            <a:avLst/>
-          </a:prstGeom>
-          <a:noFill/>
-        </p:spPr>
-        <p:txBody>
-          <a:bodyPr wrap="square" lIns="0" rIns="0" tIns="0" bIns="0">
-            <a:noAutofit/>
-          </a:bodyPr>
-          <a:lstStyle/>
-          <a:p>
-            <a:pPr algn="l">
-              <a:lnSpc>
-                <a:spcPct val="114000"/>
-              </a:lnSpc>
-              <a:spcBef>
-                <a:spcPts val="0"/>
-              </a:spcBef>
-              <a:spcAft>
-                <a:spcPts val="400"/>
-              </a:spcAft>
-              <a:buNone/>
-              <a:defRPr sz="1800" b="0">
-                <a:solidFill>
-                  <a:srgbClr val="303437"/>
-                </a:solidFill>
-                <a:latin typeface="Noto Sans"/>
-              </a:defRPr>
-            </a:pPr>
-            <a:r>
-              <a:rPr sz="1800" b="1" lang="ja-JP" altLang="en-US">
-                <a:solidFill>
-                  <a:srgbClr val="303437"/>
-                </a:solidFill>
-                <a:latin typeface="Noto Sans"/>
-                <a:ea typeface="Noto Sans CJK JP"/>
-                <a:cs typeface="Noto Sans"/>
-              </a:rPr>
-              <a:t>CLEVAInstructionFollowingScenario</a:t>
-            </a:r>
-          </a:p>
-          <a:p>
-            <a:pPr algn="l">
-              <a:lnSpc>
-                <a:spcPct val="114000"/>
-              </a:lnSpc>
-              <a:spcBef>
-                <a:spcPts val="0"/>
-              </a:spcBef>
-              <a:spcAft>
-                <a:spcPts val="500"/>
-              </a:spcAft>
-              <a:buNone/>
-              <a:defRPr sz="1250" b="0">
-                <a:solidFill>
-                  <a:srgbClr val="303437"/>
-                </a:solidFill>
-                <a:latin typeface="Noto Sans"/>
-              </a:defRPr>
-            </a:pPr>
-            <a:r>
-              <a:rPr sz="1250" b="0" lang="ja-JP" altLang="en-US">
-                <a:solidFill>
-                  <a:srgbClr val="626669"/>
-                </a:solidFill>
-                <a:latin typeface="Noto Sans"/>
-                <a:ea typeface="Noto Sans CJK JP"/>
-                <a:cs typeface="Noto Sans"/>
-              </a:rPr>
-              <a:t>Stanford CRFM (2023). HELM v0.4.0、公式Python実装。</a:t>
-            </a:r>
-          </a:p>
-          <a:p>
-            <a:pPr algn="l">
-              <a:lnSpc>
-                <a:spcPct val="114000"/>
-              </a:lnSpc>
-              <a:spcBef>
-                <a:spcPts val="0"/>
-              </a:spcBef>
-              <a:spcAft>
-                <a:spcPts val="400"/>
-              </a:spcAft>
-              <a:buNone/>
-              <a:defRPr sz="1750" b="0">
-                <a:solidFill>
-                  <a:srgbClr val="303437"/>
-                </a:solidFill>
-                <a:latin typeface="Noto Sans"/>
-              </a:defRPr>
-            </a:pPr>
-            <a:r>
-              <a:rPr sz="1750" b="0" lang="ja-JP" altLang="en-US">
-                <a:solidFill>
-                  <a:srgbClr val="303437"/>
-                </a:solidFill>
-                <a:latin typeface="Noto Sans"/>
-                <a:ea typeface="Noto Sans CJK JP"/>
-                <a:cs typeface="Noto Sans"/>
-              </a:rPr>
-              <a:t>o/xの交互列に関する中国語の説明例と正解Bを示し、CLEVA形式をHELMへ適用する。</a:t>
-            </a:r>
-          </a:p>
-          <a:p>
-            <a:pPr algn="l">
-              <a:lnSpc>
-                <a:spcPct val="114000"/>
-              </a:lnSpc>
-              <a:spcBef>
-                <a:spcPts val="0"/>
-              </a:spcBef>
-              <a:spcAft>
-                <a:spcPts val="0"/>
-              </a:spcAft>
-              <a:buNone/>
-              <a:defRPr sz="1050" b="0">
-                <a:solidFill>
-                  <a:srgbClr val="303437"/>
-                </a:solidFill>
-                <a:latin typeface="Noto Sans"/>
-              </a:defRPr>
-            </a:pPr>
-            <a:r>
-              <a:rPr sz="1050" b="0" lang="ja-JP" altLang="en-US">
-                <a:solidFill>
-                  <a:srgbClr val="626669"/>
-                </a:solidFill>
-                <a:latin typeface="Noto Sans"/>
-                <a:ea typeface="Noto Sans CJK JP"/>
-                <a:cs typeface="Noto Sans"/>
-                <a:hlinkClick r:id="rId2"/>
-              </a:rPr>
-              <a:t>https://github.com/stanford-crfm/helm/blob/v0.4.0/src/helm/benchmark/scenarios/cleva_scenario.py</a:t>
-            </a:r>
-          </a:p>
-        </p:txBody>
-      </p:sp>
-      <p:sp>
-        <p:nvSpPr>
-          <p:cNvPr id="5" name="文献 2: Attribution 4.0 International (CC BY 4.0)"/>
-          <p:cNvSpPr txBox="1"/>
-          <p:nvPr/>
-        </p:nvSpPr>
-        <p:spPr>
-          <a:xfrm>
-            <a:off x="548640" y="2987548"/>
-            <a:ext cx="8046720" cy="1233184"/>
-          </a:xfrm>
-          <a:prstGeom prst="rect">
-            <a:avLst/>
-          </a:prstGeom>
-          <a:noFill/>
-        </p:spPr>
-        <p:txBody>
-          <a:bodyPr wrap="square" lIns="0" rIns="0" tIns="0" bIns="0">
-            <a:noAutofit/>
-          </a:bodyPr>
-          <a:lstStyle/>
-          <a:p>
-            <a:pPr algn="l">
-              <a:lnSpc>
-                <a:spcPct val="114000"/>
-              </a:lnSpc>
-              <a:spcBef>
-                <a:spcPts val="0"/>
-              </a:spcBef>
-              <a:spcAft>
-                <a:spcPts val="400"/>
-              </a:spcAft>
-              <a:buNone/>
-              <a:defRPr sz="1800" b="0">
-                <a:solidFill>
-                  <a:srgbClr val="303437"/>
-                </a:solidFill>
-                <a:latin typeface="Noto Sans"/>
-              </a:defRPr>
-            </a:pPr>
-            <a:r>
-              <a:rPr sz="1800" b="1" lang="ja-JP" altLang="en-US">
-                <a:solidFill>
-                  <a:srgbClr val="303437"/>
-                </a:solidFill>
-                <a:latin typeface="Noto Sans"/>
-                <a:ea typeface="Noto Sans CJK JP"/>
-                <a:cs typeface="Noto Sans"/>
-              </a:rPr>
-              <a:t>Attribution 4.0 International (CC BY 4.0)</a:t>
-            </a:r>
-          </a:p>
-          <a:p>
-            <a:pPr algn="l">
-              <a:lnSpc>
-                <a:spcPct val="114000"/>
-              </a:lnSpc>
-              <a:spcBef>
-                <a:spcPts val="0"/>
-              </a:spcBef>
-              <a:spcAft>
-                <a:spcPts val="500"/>
-              </a:spcAft>
-              <a:buNone/>
-              <a:defRPr sz="1250" b="0">
-                <a:solidFill>
-                  <a:srgbClr val="303437"/>
-                </a:solidFill>
-                <a:latin typeface="Noto Sans"/>
-              </a:defRPr>
-            </a:pPr>
-            <a:r>
-              <a:rPr sz="1250" b="0" lang="ja-JP" altLang="en-US">
-                <a:solidFill>
-                  <a:srgbClr val="626669"/>
-                </a:solidFill>
-                <a:latin typeface="Noto Sans"/>
-                <a:ea typeface="Noto Sans CJK JP"/>
-                <a:cs typeface="Noto Sans"/>
-              </a:rPr>
-              <a:t>Creative Commons. データ公開READMEが指定する利用条件。</a:t>
-            </a:r>
-          </a:p>
-          <a:p>
-            <a:pPr algn="l">
-              <a:lnSpc>
-                <a:spcPct val="114000"/>
-              </a:lnSpc>
-              <a:spcBef>
-                <a:spcPts val="0"/>
-              </a:spcBef>
-              <a:spcAft>
-                <a:spcPts val="400"/>
-              </a:spcAft>
-              <a:buNone/>
-              <a:defRPr sz="1750" b="0">
-                <a:solidFill>
-                  <a:srgbClr val="303437"/>
-                </a:solidFill>
-                <a:latin typeface="Noto Sans"/>
-              </a:defRPr>
-            </a:pPr>
-            <a:r>
-              <a:rPr sz="1750" b="0" lang="ja-JP" altLang="en-US">
-                <a:solidFill>
-                  <a:srgbClr val="303437"/>
-                </a:solidFill>
-                <a:latin typeface="Noto Sans"/>
-                <a:ea typeface="Noto Sans CJK JP"/>
-                <a:cs typeface="Noto Sans"/>
-              </a:rPr>
-              <a:t>帰属・ライセンスへのリンク・変更の表示など、利用時の条件を定める。</a:t>
+              <a:t>帰属・ライセンスへのリンク・変更の表示など、公開データ利用時の条件を定める。</a:t>
             </a:r>
           </a:p>
           <a:p>

</xml_diff>